<commit_message>
CL1 topics 1-5: rebuild decks from the aligned slide plans
143 slides, 95 teacher notes carried through. Section references renumbered,
sensitivity analysis out of topic 3, topic 5 now points at the Business Case's
own Feedback section and drops the speaker-notes requirement.

Rendered and reviewed the changed slides in topics 3 and 5 — no overflow or
clipping. All five within the 25 MB size guideline (topic 1 is 8.12 MB, the
rest under 0.3 MB).

Co-Authored-By: Claude Opus 5 (1M context) <noreply@anthropic.com>
</commit_message>
<xml_diff>
--- a/S1-CL1-Cloud-Design-Build/delivery/topic_04/Topic_04_Slides.pptx
+++ b/S1-CL1-Cloud-Design-Build/delivery/topic_04/Topic_04_Slides.pptx
@@ -4,35 +4,32 @@
   <p:sldMasterIdLst>
     <p:sldMasterId id="2147483648" r:id="rId1"/>
   </p:sldMasterIdLst>
-  <p:notesMasterIdLst>
-    <p:notesMasterId r:id="rId25"/>
-  </p:notesMasterIdLst>
   <p:sldIdLst>
-    <p:sldId id="256" r:id="rId2"/>
-    <p:sldId id="257" r:id="rId3"/>
-    <p:sldId id="258" r:id="rId4"/>
-    <p:sldId id="259" r:id="rId5"/>
-    <p:sldId id="260" r:id="rId6"/>
-    <p:sldId id="261" r:id="rId7"/>
-    <p:sldId id="262" r:id="rId8"/>
-    <p:sldId id="263" r:id="rId9"/>
-    <p:sldId id="264" r:id="rId10"/>
-    <p:sldId id="265" r:id="rId11"/>
-    <p:sldId id="266" r:id="rId12"/>
-    <p:sldId id="267" r:id="rId13"/>
-    <p:sldId id="268" r:id="rId14"/>
-    <p:sldId id="269" r:id="rId15"/>
-    <p:sldId id="270" r:id="rId16"/>
-    <p:sldId id="271" r:id="rId17"/>
-    <p:sldId id="272" r:id="rId18"/>
-    <p:sldId id="273" r:id="rId19"/>
-    <p:sldId id="274" r:id="rId20"/>
-    <p:sldId id="275" r:id="rId21"/>
-    <p:sldId id="276" r:id="rId22"/>
-    <p:sldId id="277" r:id="rId23"/>
-    <p:sldId id="278" r:id="rId24"/>
+    <p:sldId id="256" r:id="rId7"/>
+    <p:sldId id="257" r:id="rId8"/>
+    <p:sldId id="258" r:id="rId10"/>
+    <p:sldId id="259" r:id="rId11"/>
+    <p:sldId id="260" r:id="rId12"/>
+    <p:sldId id="261" r:id="rId13"/>
+    <p:sldId id="262" r:id="rId14"/>
+    <p:sldId id="263" r:id="rId15"/>
+    <p:sldId id="264" r:id="rId16"/>
+    <p:sldId id="265" r:id="rId17"/>
+    <p:sldId id="266" r:id="rId18"/>
+    <p:sldId id="267" r:id="rId19"/>
+    <p:sldId id="268" r:id="rId20"/>
+    <p:sldId id="269" r:id="rId21"/>
+    <p:sldId id="270" r:id="rId22"/>
+    <p:sldId id="271" r:id="rId23"/>
+    <p:sldId id="272" r:id="rId24"/>
+    <p:sldId id="273" r:id="rId25"/>
+    <p:sldId id="274" r:id="rId26"/>
+    <p:sldId id="275" r:id="rId27"/>
+    <p:sldId id="276" r:id="rId28"/>
+    <p:sldId id="277" r:id="rId29"/>
+    <p:sldId id="278" r:id="rId30"/>
   </p:sldIdLst>
-  <p:sldSz cx="12192000" cy="6858000"/>
+  <p:sldSz cx="12191695" cy="6858000" type="screen4x3"/>
   <p:notesSz cx="6858000" cy="9144000"/>
   <p:defaultTextStyle>
     <a:defPPr>
@@ -129,27 +126,11 @@
       </a:defRPr>
     </a:lvl9pPr>
   </p:defaultTextStyle>
-  <p:extLst>
-    <p:ext uri="{EFAFB233-063F-42B5-8137-9DF3F51BA10A}">
-      <p15:sldGuideLst xmlns:p15="http://schemas.microsoft.com/office/powerpoint/2012/main">
-        <p15:guide id="1" orient="horz" pos="2160">
-          <p15:clr>
-            <a:srgbClr val="A4A3A4"/>
-          </p15:clr>
-        </p15:guide>
-        <p15:guide id="2" pos="2880">
-          <p15:clr>
-            <a:srgbClr val="A4A3A4"/>
-          </p15:clr>
-        </p15:guide>
-      </p15:sldGuideLst>
-    </p:ext>
-  </p:extLst>
 </p:presentation>
 </file>
 
 <file path=ppt/notesMasters/notesMaster1.xml><?xml version="1.0" encoding="utf-8"?>
-<p:notesMaster xmlns:a="http://schemas.openxmlformats.org/drawingml/2006/main" xmlns:r="http://schemas.openxmlformats.org/officeDocument/2006/relationships" xmlns:p="http://schemas.openxmlformats.org/presentationml/2006/main">
+<p:notesMaster xmlns:a="http://schemas.openxmlformats.org/drawingml/2006/main" xmlns:p="http://schemas.openxmlformats.org/presentationml/2006/main" xmlns:r="http://schemas.openxmlformats.org/officeDocument/2006/relationships">
   <p:cSld>
     <p:bg>
       <p:bgRef idx="1001">
@@ -183,7 +164,7 @@
         <p:spPr>
           <a:xfrm>
             <a:off x="0" y="0"/>
-            <a:ext cx="2971800" cy="458788"/>
+            <a:ext cx="2971800" cy="457200"/>
           </a:xfrm>
           <a:prstGeom prst="rect">
             <a:avLst/>
@@ -214,7 +195,7 @@
         <p:spPr>
           <a:xfrm>
             <a:off x="3884613" y="0"/>
-            <a:ext cx="2971800" cy="458788"/>
+            <a:ext cx="2971800" cy="457200"/>
           </a:xfrm>
           <a:prstGeom prst="rect">
             <a:avLst/>
@@ -228,9 +209,9 @@
             </a:lvl1pPr>
           </a:lstStyle>
           <a:p>
-            <a:fld id="{65ECCCC9-759E-4241-83C9-0B1A92B4ECDF}" type="datetimeFigureOut">
+            <a:fld id="{0F89C1C7-3DCD-1040-A9CF-14679D8B5DDD}" type="datetimeFigureOut">
               <a:rPr lang="en-US" smtClean="0"/>
-              <a:t>7/16/26</a:t>
+              <a:t>10/17/16</a:t>
             </a:fld>
             <a:endParaRPr lang="en-US"/>
           </a:p>
@@ -248,8 +229,8 @@
         </p:nvSpPr>
         <p:spPr>
           <a:xfrm>
-            <a:off x="685800" y="1143000"/>
-            <a:ext cx="5486400" cy="3086100"/>
+            <a:off x="1143000" y="685800"/>
+            <a:ext cx="4572000" cy="3429000"/>
           </a:xfrm>
           <a:prstGeom prst="rect">
             <a:avLst/>
@@ -281,8 +262,8 @@
         </p:nvSpPr>
         <p:spPr>
           <a:xfrm>
-            <a:off x="685800" y="4400550"/>
-            <a:ext cx="5486400" cy="3600450"/>
+            <a:off x="685800" y="4343400"/>
+            <a:ext cx="5486400" cy="4114800"/>
           </a:xfrm>
           <a:prstGeom prst="rect">
             <a:avLst/>
@@ -294,35 +275,35 @@
           <a:p>
             <a:pPr lvl="0"/>
             <a:r>
-              <a:rPr lang="en-GB"/>
+              <a:rPr lang="en-US" smtClean="0"/>
               <a:t>Click to edit Master text styles</a:t>
             </a:r>
           </a:p>
           <a:p>
             <a:pPr lvl="1"/>
             <a:r>
-              <a:rPr lang="en-GB"/>
+              <a:rPr lang="en-US" smtClean="0"/>
               <a:t>Second level</a:t>
             </a:r>
           </a:p>
           <a:p>
             <a:pPr lvl="2"/>
             <a:r>
-              <a:rPr lang="en-GB"/>
+              <a:rPr lang="en-US" smtClean="0"/>
               <a:t>Third level</a:t>
             </a:r>
           </a:p>
           <a:p>
             <a:pPr lvl="3"/>
             <a:r>
-              <a:rPr lang="en-GB"/>
+              <a:rPr lang="en-US" smtClean="0"/>
               <a:t>Fourth level</a:t>
             </a:r>
           </a:p>
           <a:p>
             <a:pPr lvl="4"/>
             <a:r>
-              <a:rPr lang="en-GB"/>
+              <a:rPr lang="en-US" smtClean="0"/>
               <a:t>Fifth level</a:t>
             </a:r>
             <a:endParaRPr lang="en-US"/>
@@ -342,7 +323,7 @@
         <p:spPr>
           <a:xfrm>
             <a:off x="0" y="8685213"/>
-            <a:ext cx="2971800" cy="458787"/>
+            <a:ext cx="2971800" cy="457200"/>
           </a:xfrm>
           <a:prstGeom prst="rect">
             <a:avLst/>
@@ -373,7 +354,7 @@
         <p:spPr>
           <a:xfrm>
             <a:off x="3884613" y="8685213"/>
-            <a:ext cx="2971800" cy="458787"/>
+            <a:ext cx="2971800" cy="457200"/>
           </a:xfrm>
           <a:prstGeom prst="rect">
             <a:avLst/>
@@ -387,7 +368,7 @@
             </a:lvl1pPr>
           </a:lstStyle>
           <a:p>
-            <a:fld id="{87D6DEE3-A7BC-0D4F-A8A9-8296E02035D5}" type="slidenum">
+            <a:fld id="{BB5E49A5-4136-284D-997B-48E1D791AD67}" type="slidenum">
               <a:rPr lang="en-US" smtClean="0"/>
               <a:t>‹#›</a:t>
             </a:fld>
@@ -398,13 +379,13 @@
     </p:spTree>
     <p:extLst>
       <p:ext uri="{BB962C8B-B14F-4D97-AF65-F5344CB8AC3E}">
-        <p14:creationId xmlns:p14="http://schemas.microsoft.com/office/powerpoint/2010/main" val="3485553459"/>
+        <p14:creationId xmlns:p14="http://schemas.microsoft.com/office/powerpoint/2010/main" val="2623252185"/>
       </p:ext>
     </p:extLst>
   </p:cSld>
   <p:clrMap bg1="lt1" tx1="dk1" bg2="lt2" tx2="dk2" accent1="accent1" accent2="accent2" accent3="accent3" accent4="accent4" accent5="accent5" accent6="accent6" hlink="hlink" folHlink="folHlink"/>
   <p:notesStyle>
-    <a:lvl1pPr marL="0" algn="l" defTabSz="914400" rtl="0" eaLnBrk="1" latinLnBrk="0" hangingPunct="1">
+    <a:lvl1pPr marL="0" algn="l" defTabSz="457200" rtl="0" eaLnBrk="1" latinLnBrk="0" hangingPunct="1">
       <a:defRPr sz="1200" kern="1200">
         <a:solidFill>
           <a:schemeClr val="tx1"/>
@@ -414,7 +395,7 @@
         <a:cs typeface="+mn-cs"/>
       </a:defRPr>
     </a:lvl1pPr>
-    <a:lvl2pPr marL="457200" algn="l" defTabSz="914400" rtl="0" eaLnBrk="1" latinLnBrk="0" hangingPunct="1">
+    <a:lvl2pPr marL="457200" algn="l" defTabSz="457200" rtl="0" eaLnBrk="1" latinLnBrk="0" hangingPunct="1">
       <a:defRPr sz="1200" kern="1200">
         <a:solidFill>
           <a:schemeClr val="tx1"/>
@@ -424,7 +405,7 @@
         <a:cs typeface="+mn-cs"/>
       </a:defRPr>
     </a:lvl2pPr>
-    <a:lvl3pPr marL="914400" algn="l" defTabSz="914400" rtl="0" eaLnBrk="1" latinLnBrk="0" hangingPunct="1">
+    <a:lvl3pPr marL="914400" algn="l" defTabSz="457200" rtl="0" eaLnBrk="1" latinLnBrk="0" hangingPunct="1">
       <a:defRPr sz="1200" kern="1200">
         <a:solidFill>
           <a:schemeClr val="tx1"/>
@@ -434,7 +415,7 @@
         <a:cs typeface="+mn-cs"/>
       </a:defRPr>
     </a:lvl3pPr>
-    <a:lvl4pPr marL="1371600" algn="l" defTabSz="914400" rtl="0" eaLnBrk="1" latinLnBrk="0" hangingPunct="1">
+    <a:lvl4pPr marL="1371600" algn="l" defTabSz="457200" rtl="0" eaLnBrk="1" latinLnBrk="0" hangingPunct="1">
       <a:defRPr sz="1200" kern="1200">
         <a:solidFill>
           <a:schemeClr val="tx1"/>
@@ -444,7 +425,7 @@
         <a:cs typeface="+mn-cs"/>
       </a:defRPr>
     </a:lvl4pPr>
-    <a:lvl5pPr marL="1828800" algn="l" defTabSz="914400" rtl="0" eaLnBrk="1" latinLnBrk="0" hangingPunct="1">
+    <a:lvl5pPr marL="1828800" algn="l" defTabSz="457200" rtl="0" eaLnBrk="1" latinLnBrk="0" hangingPunct="1">
       <a:defRPr sz="1200" kern="1200">
         <a:solidFill>
           <a:schemeClr val="tx1"/>
@@ -454,7 +435,7 @@
         <a:cs typeface="+mn-cs"/>
       </a:defRPr>
     </a:lvl5pPr>
-    <a:lvl6pPr marL="2286000" algn="l" defTabSz="914400" rtl="0" eaLnBrk="1" latinLnBrk="0" hangingPunct="1">
+    <a:lvl6pPr marL="2286000" algn="l" defTabSz="457200" rtl="0" eaLnBrk="1" latinLnBrk="0" hangingPunct="1">
       <a:defRPr sz="1200" kern="1200">
         <a:solidFill>
           <a:schemeClr val="tx1"/>
@@ -464,7 +445,7 @@
         <a:cs typeface="+mn-cs"/>
       </a:defRPr>
     </a:lvl6pPr>
-    <a:lvl7pPr marL="2743200" algn="l" defTabSz="914400" rtl="0" eaLnBrk="1" latinLnBrk="0" hangingPunct="1">
+    <a:lvl7pPr marL="2743200" algn="l" defTabSz="457200" rtl="0" eaLnBrk="1" latinLnBrk="0" hangingPunct="1">
       <a:defRPr sz="1200" kern="1200">
         <a:solidFill>
           <a:schemeClr val="tx1"/>
@@ -474,7 +455,7 @@
         <a:cs typeface="+mn-cs"/>
       </a:defRPr>
     </a:lvl7pPr>
-    <a:lvl8pPr marL="3200400" algn="l" defTabSz="914400" rtl="0" eaLnBrk="1" latinLnBrk="0" hangingPunct="1">
+    <a:lvl8pPr marL="3200400" algn="l" defTabSz="457200" rtl="0" eaLnBrk="1" latinLnBrk="0" hangingPunct="1">
       <a:defRPr sz="1200" kern="1200">
         <a:solidFill>
           <a:schemeClr val="tx1"/>
@@ -484,7 +465,7 @@
         <a:cs typeface="+mn-cs"/>
       </a:defRPr>
     </a:lvl8pPr>
-    <a:lvl9pPr marL="3657600" algn="l" defTabSz="914400" rtl="0" eaLnBrk="1" latinLnBrk="0" hangingPunct="1">
+    <a:lvl9pPr marL="3657600" algn="l" defTabSz="457200" rtl="0" eaLnBrk="1" latinLnBrk="0" hangingPunct="1">
       <a:defRPr sz="1200" kern="1200">
         <a:solidFill>
           <a:schemeClr val="tx1"/>
@@ -499,7 +480,7 @@
 </file>
 
 <file path=ppt/notesSlides/notesSlide1.xml><?xml version="1.0" encoding="utf-8"?>
-<p:notes xmlns:a="http://schemas.openxmlformats.org/drawingml/2006/main" xmlns:r="http://schemas.openxmlformats.org/officeDocument/2006/relationships" xmlns:p="http://schemas.openxmlformats.org/presentationml/2006/main">
+<p:notes xmlns:a="http://schemas.openxmlformats.org/drawingml/2006/main" xmlns:p="http://schemas.openxmlformats.org/presentationml/2006/main" xmlns:r="http://schemas.openxmlformats.org/officeDocument/2006/relationships">
   <p:cSld>
     <p:spTree>
       <p:nvGrpSpPr>
@@ -519,7 +500,7 @@
         <p:nvSpPr>
           <p:cNvPr id="2" name="Slide Image Placeholder 1"/>
           <p:cNvSpPr>
-            <a:spLocks noGrp="1" noRot="1" noChangeAspect="1"/>
+            <a:spLocks noGrp="1"/>
           </p:cNvSpPr>
           <p:nvPr>
             <p:ph type="sldImg" idx="2"/>
@@ -534,7 +515,7 @@
             <a:spLocks noGrp="1"/>
           </p:cNvSpPr>
           <p:nvPr>
-            <p:ph type="body" sz="quarter" idx="3"/>
+            <p:ph type="body" idx="3" sz="quarter"/>
           </p:nvPr>
         </p:nvSpPr>
         <p:spPr/>
@@ -578,7 +559,7 @@
           </a:p>
           <a:p>
             <a:r>
-              <a:t>build §3–§5, §6–§8, §9–§11). Only the pitch (Topic 5) remains.</a:t>
+              <a:t>build §2–§4, §5–§7, §8–§10). Only the pitch (Topic 5) remains.</a:t>
             </a:r>
           </a:p>
           <a:p>
@@ -613,7 +594,7 @@
           </a:p>
           <a:p>
             <a:r>
-              <a:t>Case §9–§11 sections.</a:t>
+              <a:t>Case §8–§10 sections.</a:t>
             </a:r>
           </a:p>
         </p:txBody>
@@ -625,7 +606,7 @@
             <a:spLocks noGrp="1"/>
           </p:cNvSpPr>
           <p:nvPr>
-            <p:ph type="sldNum" sz="quarter" idx="5"/>
+            <p:ph type="sldNum" idx="5" sz="quarter"/>
           </p:nvPr>
         </p:nvSpPr>
         <p:spPr/>
@@ -639,7 +620,7 @@
 </file>
 
 <file path=ppt/notesSlides/notesSlide10.xml><?xml version="1.0" encoding="utf-8"?>
-<p:notes xmlns:a="http://schemas.openxmlformats.org/drawingml/2006/main" xmlns:r="http://schemas.openxmlformats.org/officeDocument/2006/relationships" xmlns:p="http://schemas.openxmlformats.org/presentationml/2006/main">
+<p:notes xmlns:a="http://schemas.openxmlformats.org/drawingml/2006/main" xmlns:p="http://schemas.openxmlformats.org/presentationml/2006/main" xmlns:r="http://schemas.openxmlformats.org/officeDocument/2006/relationships">
   <p:cSld>
     <p:spTree>
       <p:nvGrpSpPr>
@@ -659,7 +640,7 @@
         <p:nvSpPr>
           <p:cNvPr id="2" name="Slide Image Placeholder 1"/>
           <p:cNvSpPr>
-            <a:spLocks noGrp="1" noRot="1" noChangeAspect="1"/>
+            <a:spLocks noGrp="1"/>
           </p:cNvSpPr>
           <p:nvPr>
             <p:ph type="sldImg" idx="2"/>
@@ -674,7 +655,7 @@
             <a:spLocks noGrp="1"/>
           </p:cNvSpPr>
           <p:nvPr>
-            <p:ph type="body" sz="quarter" idx="3"/>
+            <p:ph type="body" idx="3" sz="quarter"/>
           </p:nvPr>
         </p:nvSpPr>
         <p:spPr/>
@@ -743,7 +724,7 @@
           </a:p>
           <a:p>
             <a:r>
-              <a:t>UoC/AT1 tie: PC 3.2 (standards, targets, implementation methods) → AT1 §10.</a:t>
+              <a:t>UoC/AT1 tie: PC 3.2 (standards, targets, implementation methods) → AT1 §9.</a:t>
             </a:r>
           </a:p>
         </p:txBody>
@@ -755,7 +736,7 @@
             <a:spLocks noGrp="1"/>
           </p:cNvSpPr>
           <p:nvPr>
-            <p:ph type="sldNum" sz="quarter" idx="5"/>
+            <p:ph type="sldNum" idx="5" sz="quarter"/>
           </p:nvPr>
         </p:nvSpPr>
         <p:spPr/>
@@ -769,7 +750,7 @@
 </file>
 
 <file path=ppt/notesSlides/notesSlide11.xml><?xml version="1.0" encoding="utf-8"?>
-<p:notes xmlns:a="http://schemas.openxmlformats.org/drawingml/2006/main" xmlns:r="http://schemas.openxmlformats.org/officeDocument/2006/relationships" xmlns:p="http://schemas.openxmlformats.org/presentationml/2006/main">
+<p:notes xmlns:a="http://schemas.openxmlformats.org/drawingml/2006/main" xmlns:p="http://schemas.openxmlformats.org/presentationml/2006/main" xmlns:r="http://schemas.openxmlformats.org/officeDocument/2006/relationships">
   <p:cSld>
     <p:spTree>
       <p:nvGrpSpPr>
@@ -789,7 +770,7 @@
         <p:nvSpPr>
           <p:cNvPr id="2" name="Slide Image Placeholder 1"/>
           <p:cNvSpPr>
-            <a:spLocks noGrp="1" noRot="1" noChangeAspect="1"/>
+            <a:spLocks noGrp="1"/>
           </p:cNvSpPr>
           <p:nvPr>
             <p:ph type="sldImg" idx="2"/>
@@ -804,7 +785,7 @@
             <a:spLocks noGrp="1"/>
           </p:cNvSpPr>
           <p:nvPr>
-            <p:ph type="body" sz="quarter" idx="3"/>
+            <p:ph type="body" idx="3" sz="quarter"/>
           </p:nvPr>
         </p:nvSpPr>
         <p:spPr/>
@@ -868,7 +849,7 @@
           </a:p>
           <a:p>
             <a:r>
-              <a:t>UoC/AT1 tie: PC 3.1 (consistency with organisational policy and procedures) → AT1 §10.</a:t>
+              <a:t>UoC/AT1 tie: PC 3.1 (consistency with organisational policy and procedures) → AT1 §9.</a:t>
             </a:r>
           </a:p>
         </p:txBody>
@@ -880,7 +861,7 @@
             <a:spLocks noGrp="1"/>
           </p:cNvSpPr>
           <p:nvPr>
-            <p:ph type="sldNum" sz="quarter" idx="5"/>
+            <p:ph type="sldNum" idx="5" sz="quarter"/>
           </p:nvPr>
         </p:nvSpPr>
         <p:spPr/>
@@ -894,7 +875,7 @@
 </file>
 
 <file path=ppt/notesSlides/notesSlide12.xml><?xml version="1.0" encoding="utf-8"?>
-<p:notes xmlns:a="http://schemas.openxmlformats.org/drawingml/2006/main" xmlns:r="http://schemas.openxmlformats.org/officeDocument/2006/relationships" xmlns:p="http://schemas.openxmlformats.org/presentationml/2006/main">
+<p:notes xmlns:a="http://schemas.openxmlformats.org/drawingml/2006/main" xmlns:p="http://schemas.openxmlformats.org/presentationml/2006/main" xmlns:r="http://schemas.openxmlformats.org/officeDocument/2006/relationships">
   <p:cSld>
     <p:spTree>
       <p:nvGrpSpPr>
@@ -914,7 +895,7 @@
         <p:nvSpPr>
           <p:cNvPr id="2" name="Slide Image Placeholder 1"/>
           <p:cNvSpPr>
-            <a:spLocks noGrp="1" noRot="1" noChangeAspect="1"/>
+            <a:spLocks noGrp="1"/>
           </p:cNvSpPr>
           <p:nvPr>
             <p:ph type="sldImg" idx="2"/>
@@ -929,7 +910,7 @@
             <a:spLocks noGrp="1"/>
           </p:cNvSpPr>
           <p:nvPr>
-            <p:ph type="body" sz="quarter" idx="3"/>
+            <p:ph type="body" idx="3" sz="quarter"/>
           </p:nvPr>
         </p:nvSpPr>
         <p:spPr/>
@@ -938,7 +919,7 @@
           <a:lstStyle/>
           <a:p>
             <a:r>
-              <a:t>Facilitation — the biggest build task of the Topic. They add §10 to their practice BC with all</a:t>
+              <a:t>Facilitation — the biggest build task of the Topic. They add §9 to their practice BC with all</a:t>
             </a:r>
           </a:p>
           <a:p>
@@ -1018,7 +999,7 @@
           </a:p>
           <a:p>
             <a:r>
-              <a:t>No-leakage note: PRACTICE on Ledgerline; AT1 assesses the same §10 plan on the LMS — comparable,</a:t>
+              <a:t>No-leakage note: PRACTICE on Ledgerline; AT1 assesses the same §9 plan on the LMS — comparable,</a:t>
             </a:r>
           </a:p>
           <a:p>
@@ -1028,7 +1009,7 @@
           </a:p>
           <a:p>
             <a:r>
-              <a:t>UoC/AT1 tie: PC 3.1 / 3.2, PE 6, KE 1 → AT1 Part A §10.</a:t>
+              <a:t>UoC/AT1 tie: PC 3.1 / 3.2, PE 6, KE 1 → AT1 Part A §9.</a:t>
             </a:r>
           </a:p>
         </p:txBody>
@@ -1040,7 +1021,7 @@
             <a:spLocks noGrp="1"/>
           </p:cNvSpPr>
           <p:nvPr>
-            <p:ph type="sldNum" sz="quarter" idx="5"/>
+            <p:ph type="sldNum" idx="5" sz="quarter"/>
           </p:nvPr>
         </p:nvSpPr>
         <p:spPr/>
@@ -1054,7 +1035,7 @@
 </file>
 
 <file path=ppt/notesSlides/notesSlide13.xml><?xml version="1.0" encoding="utf-8"?>
-<p:notes xmlns:a="http://schemas.openxmlformats.org/drawingml/2006/main" xmlns:r="http://schemas.openxmlformats.org/officeDocument/2006/relationships" xmlns:p="http://schemas.openxmlformats.org/presentationml/2006/main">
+<p:notes xmlns:a="http://schemas.openxmlformats.org/drawingml/2006/main" xmlns:p="http://schemas.openxmlformats.org/presentationml/2006/main" xmlns:r="http://schemas.openxmlformats.org/officeDocument/2006/relationships">
   <p:cSld>
     <p:spTree>
       <p:nvGrpSpPr>
@@ -1074,7 +1055,7 @@
         <p:nvSpPr>
           <p:cNvPr id="2" name="Slide Image Placeholder 1"/>
           <p:cNvSpPr>
-            <a:spLocks noGrp="1" noRot="1" noChangeAspect="1"/>
+            <a:spLocks noGrp="1"/>
           </p:cNvSpPr>
           <p:nvPr>
             <p:ph type="sldImg" idx="2"/>
@@ -1089,7 +1070,7 @@
             <a:spLocks noGrp="1"/>
           </p:cNvSpPr>
           <p:nvPr>
-            <p:ph type="body" sz="quarter" idx="3"/>
+            <p:ph type="body" idx="3" sz="quarter"/>
           </p:nvPr>
         </p:nvSpPr>
         <p:spPr/>
@@ -1153,7 +1134,7 @@
           </a:p>
           <a:p>
             <a:r>
-              <a:t>UoC/AT1 tie: opens PC 3.3 (provide action plan for feedback/approval — the written ask) → AT1 §11.</a:t>
+              <a:t>UoC/AT1 tie: opens PC 3.3 (provide action plan for feedback/approval — the written ask) → AT1 §10.</a:t>
             </a:r>
           </a:p>
         </p:txBody>
@@ -1165,7 +1146,7 @@
             <a:spLocks noGrp="1"/>
           </p:cNvSpPr>
           <p:nvPr>
-            <p:ph type="sldNum" sz="quarter" idx="5"/>
+            <p:ph type="sldNum" idx="5" sz="quarter"/>
           </p:nvPr>
         </p:nvSpPr>
         <p:spPr/>
@@ -1179,7 +1160,7 @@
 </file>
 
 <file path=ppt/notesSlides/notesSlide14.xml><?xml version="1.0" encoding="utf-8"?>
-<p:notes xmlns:a="http://schemas.openxmlformats.org/drawingml/2006/main" xmlns:r="http://schemas.openxmlformats.org/officeDocument/2006/relationships" xmlns:p="http://schemas.openxmlformats.org/presentationml/2006/main">
+<p:notes xmlns:a="http://schemas.openxmlformats.org/drawingml/2006/main" xmlns:p="http://schemas.openxmlformats.org/presentationml/2006/main" xmlns:r="http://schemas.openxmlformats.org/officeDocument/2006/relationships">
   <p:cSld>
     <p:spTree>
       <p:nvGrpSpPr>
@@ -1199,7 +1180,7 @@
         <p:nvSpPr>
           <p:cNvPr id="2" name="Slide Image Placeholder 1"/>
           <p:cNvSpPr>
-            <a:spLocks noGrp="1" noRot="1" noChangeAspect="1"/>
+            <a:spLocks noGrp="1"/>
           </p:cNvSpPr>
           <p:nvPr>
             <p:ph type="sldImg" idx="2"/>
@@ -1214,7 +1195,7 @@
             <a:spLocks noGrp="1"/>
           </p:cNvSpPr>
           <p:nvPr>
-            <p:ph type="body" sz="quarter" idx="3"/>
+            <p:ph type="body" idx="3" sz="quarter"/>
           </p:nvPr>
         </p:nvSpPr>
         <p:spPr/>
@@ -1228,7 +1209,7 @@
           </a:p>
           <a:p>
             <a:r>
-              <a:t>the slide that makes §11 concrete.</a:t>
+              <a:t>the slide that makes §10 concrete.</a:t>
             </a:r>
           </a:p>
           <a:p>
@@ -1288,7 +1269,7 @@
           </a:p>
           <a:p>
             <a:r>
-              <a:t>UoC/AT1 tie: PC 3.3 → AT1 §11 Next Steps and Decision Requested.</a:t>
+              <a:t>UoC/AT1 tie: PC 3.3 → AT1 §10 Next Steps and Decision Requested.</a:t>
             </a:r>
           </a:p>
         </p:txBody>
@@ -1300,7 +1281,7 @@
             <a:spLocks noGrp="1"/>
           </p:cNvSpPr>
           <p:nvPr>
-            <p:ph type="sldNum" sz="quarter" idx="5"/>
+            <p:ph type="sldNum" idx="5" sz="quarter"/>
           </p:nvPr>
         </p:nvSpPr>
         <p:spPr/>
@@ -1314,7 +1295,7 @@
 </file>
 
 <file path=ppt/notesSlides/notesSlide15.xml><?xml version="1.0" encoding="utf-8"?>
-<p:notes xmlns:a="http://schemas.openxmlformats.org/drawingml/2006/main" xmlns:r="http://schemas.openxmlformats.org/officeDocument/2006/relationships" xmlns:p="http://schemas.openxmlformats.org/presentationml/2006/main">
+<p:notes xmlns:a="http://schemas.openxmlformats.org/drawingml/2006/main" xmlns:p="http://schemas.openxmlformats.org/presentationml/2006/main" xmlns:r="http://schemas.openxmlformats.org/officeDocument/2006/relationships">
   <p:cSld>
     <p:spTree>
       <p:nvGrpSpPr>
@@ -1334,7 +1315,7 @@
         <p:nvSpPr>
           <p:cNvPr id="2" name="Slide Image Placeholder 1"/>
           <p:cNvSpPr>
-            <a:spLocks noGrp="1" noRot="1" noChangeAspect="1"/>
+            <a:spLocks noGrp="1"/>
           </p:cNvSpPr>
           <p:nvPr>
             <p:ph type="sldImg" idx="2"/>
@@ -1349,7 +1330,7 @@
             <a:spLocks noGrp="1"/>
           </p:cNvSpPr>
           <p:nvPr>
-            <p:ph type="body" sz="quarter" idx="3"/>
+            <p:ph type="body" idx="3" sz="quarter"/>
           </p:nvPr>
         </p:nvSpPr>
         <p:spPr/>
@@ -1413,7 +1394,7 @@
           </a:p>
           <a:p>
             <a:r>
-              <a:t>practice BC is COMPLETE (§3–§11).</a:t>
+              <a:t>practice BC is COMPLETE (§2–§10).</a:t>
             </a:r>
           </a:p>
           <a:p>
@@ -1443,7 +1424,7 @@
           </a:p>
           <a:p>
             <a:r>
-              <a:t>No-leakage note: PRACTICE on Ledgerline; AT1 assesses the same §11 on the LMS — comparable, not</a:t>
+              <a:t>No-leakage note: PRACTICE on Ledgerline; AT1 assesses the same §10 on the LMS — comparable, not</a:t>
             </a:r>
           </a:p>
           <a:p>
@@ -1453,7 +1434,7 @@
           </a:p>
           <a:p>
             <a:r>
-              <a:t>UoC/AT1 tie: PC 3.3 → AT1 Part A §11 (Topic 5 then DELIVERS the pitch — PC 3.3's live approval).</a:t>
+              <a:t>UoC/AT1 tie: PC 3.3 → AT1 Part A §10 (Topic 5 then DELIVERS the pitch — PC 3.3's live approval).</a:t>
             </a:r>
           </a:p>
         </p:txBody>
@@ -1465,7 +1446,7 @@
             <a:spLocks noGrp="1"/>
           </p:cNvSpPr>
           <p:nvPr>
-            <p:ph type="sldNum" sz="quarter" idx="5"/>
+            <p:ph type="sldNum" idx="5" sz="quarter"/>
           </p:nvPr>
         </p:nvSpPr>
         <p:spPr/>
@@ -1479,7 +1460,7 @@
 </file>
 
 <file path=ppt/notesSlides/notesSlide2.xml><?xml version="1.0" encoding="utf-8"?>
-<p:notes xmlns:a="http://schemas.openxmlformats.org/drawingml/2006/main" xmlns:r="http://schemas.openxmlformats.org/officeDocument/2006/relationships" xmlns:p="http://schemas.openxmlformats.org/presentationml/2006/main">
+<p:notes xmlns:a="http://schemas.openxmlformats.org/drawingml/2006/main" xmlns:p="http://schemas.openxmlformats.org/presentationml/2006/main" xmlns:r="http://schemas.openxmlformats.org/officeDocument/2006/relationships">
   <p:cSld>
     <p:spTree>
       <p:nvGrpSpPr>
@@ -1499,7 +1480,7 @@
         <p:nvSpPr>
           <p:cNvPr id="2" name="Slide Image Placeholder 1"/>
           <p:cNvSpPr>
-            <a:spLocks noGrp="1" noRot="1" noChangeAspect="1"/>
+            <a:spLocks noGrp="1"/>
           </p:cNvSpPr>
           <p:nvPr>
             <p:ph type="sldImg" idx="2"/>
@@ -1514,7 +1495,7 @@
             <a:spLocks noGrp="1"/>
           </p:cNvSpPr>
           <p:nvPr>
-            <p:ph type="body" sz="quarter" idx="3"/>
+            <p:ph type="body" idx="3" sz="quarter"/>
           </p:nvPr>
         </p:nvSpPr>
         <p:spPr/>
@@ -1583,7 +1564,7 @@
           </a:p>
           <a:p>
             <a:r>
-              <a:t>UoC/AT1 tie: opens PC 2.3 / PE 4 (prioritise + recommend) → AT1 §9 Recommendation.</a:t>
+              <a:t>UoC/AT1 tie: opens PC 2.3 / PE 4 (prioritise + recommend) → AT1 §8 Recommendation.</a:t>
             </a:r>
           </a:p>
         </p:txBody>
@@ -1595,7 +1576,7 @@
             <a:spLocks noGrp="1"/>
           </p:cNvSpPr>
           <p:nvPr>
-            <p:ph type="sldNum" sz="quarter" idx="5"/>
+            <p:ph type="sldNum" idx="5" sz="quarter"/>
           </p:nvPr>
         </p:nvSpPr>
         <p:spPr/>
@@ -1609,7 +1590,7 @@
 </file>
 
 <file path=ppt/notesSlides/notesSlide3.xml><?xml version="1.0" encoding="utf-8"?>
-<p:notes xmlns:a="http://schemas.openxmlformats.org/drawingml/2006/main" xmlns:r="http://schemas.openxmlformats.org/officeDocument/2006/relationships" xmlns:p="http://schemas.openxmlformats.org/presentationml/2006/main">
+<p:notes xmlns:a="http://schemas.openxmlformats.org/drawingml/2006/main" xmlns:p="http://schemas.openxmlformats.org/presentationml/2006/main" xmlns:r="http://schemas.openxmlformats.org/officeDocument/2006/relationships">
   <p:cSld>
     <p:spTree>
       <p:nvGrpSpPr>
@@ -1629,7 +1610,7 @@
         <p:nvSpPr>
           <p:cNvPr id="2" name="Slide Image Placeholder 1"/>
           <p:cNvSpPr>
-            <a:spLocks noGrp="1" noRot="1" noChangeAspect="1"/>
+            <a:spLocks noGrp="1"/>
           </p:cNvSpPr>
           <p:nvPr>
             <p:ph type="sldImg" idx="2"/>
@@ -1644,7 +1625,7 @@
             <a:spLocks noGrp="1"/>
           </p:cNvSpPr>
           <p:nvPr>
-            <p:ph type="body" sz="quarter" idx="3"/>
+            <p:ph type="body" idx="3" sz="quarter"/>
           </p:nvPr>
         </p:nvSpPr>
         <p:spPr/>
@@ -1713,7 +1694,7 @@
           </a:p>
           <a:p>
             <a:r>
-              <a:t>UoC/AT1 tie: PC 2.3 (prioritise proposed changes to assist scheduling) + PE 4 → AT1 §9.</a:t>
+              <a:t>UoC/AT1 tie: PC 2.3 (prioritise proposed changes to assist scheduling) + PE 4 → AT1 §8.</a:t>
             </a:r>
           </a:p>
         </p:txBody>
@@ -1725,7 +1706,7 @@
             <a:spLocks noGrp="1"/>
           </p:cNvSpPr>
           <p:nvPr>
-            <p:ph type="sldNum" sz="quarter" idx="5"/>
+            <p:ph type="sldNum" idx="5" sz="quarter"/>
           </p:nvPr>
         </p:nvSpPr>
         <p:spPr/>
@@ -1739,7 +1720,7 @@
 </file>
 
 <file path=ppt/notesSlides/notesSlide4.xml><?xml version="1.0" encoding="utf-8"?>
-<p:notes xmlns:a="http://schemas.openxmlformats.org/drawingml/2006/main" xmlns:r="http://schemas.openxmlformats.org/officeDocument/2006/relationships" xmlns:p="http://schemas.openxmlformats.org/presentationml/2006/main">
+<p:notes xmlns:a="http://schemas.openxmlformats.org/drawingml/2006/main" xmlns:p="http://schemas.openxmlformats.org/presentationml/2006/main" xmlns:r="http://schemas.openxmlformats.org/officeDocument/2006/relationships">
   <p:cSld>
     <p:spTree>
       <p:nvGrpSpPr>
@@ -1759,7 +1740,7 @@
         <p:nvSpPr>
           <p:cNvPr id="2" name="Slide Image Placeholder 1"/>
           <p:cNvSpPr>
-            <a:spLocks noGrp="1" noRot="1" noChangeAspect="1"/>
+            <a:spLocks noGrp="1"/>
           </p:cNvSpPr>
           <p:nvPr>
             <p:ph type="sldImg" idx="2"/>
@@ -1774,7 +1755,7 @@
             <a:spLocks noGrp="1"/>
           </p:cNvSpPr>
           <p:nvPr>
-            <p:ph type="body" sz="quarter" idx="3"/>
+            <p:ph type="body" idx="3" sz="quarter"/>
           </p:nvPr>
         </p:nvSpPr>
         <p:spPr/>
@@ -1803,7 +1784,7 @@
           </a:p>
           <a:p>
             <a:r>
-              <a:t>the risk / impact comparison, and alignment with the strategic objectives (§3).</a:t>
+              <a:t>the risk / impact comparison, and alignment with the strategic objectives (§2).</a:t>
             </a:r>
           </a:p>
           <a:p>
@@ -1838,7 +1819,7 @@
           </a:p>
           <a:p>
             <a:r>
-              <a:t>UoC/AT1 tie: PC 2.3 / PE 4 → AT1 §9 — the recommended option with evidence-linked justification.</a:t>
+              <a:t>UoC/AT1 tie: PC 2.3 / PE 4 → AT1 §8 — the recommended option with evidence-linked justification.</a:t>
             </a:r>
           </a:p>
         </p:txBody>
@@ -1850,7 +1831,7 @@
             <a:spLocks noGrp="1"/>
           </p:cNvSpPr>
           <p:nvPr>
-            <p:ph type="sldNum" sz="quarter" idx="5"/>
+            <p:ph type="sldNum" idx="5" sz="quarter"/>
           </p:nvPr>
         </p:nvSpPr>
         <p:spPr/>
@@ -1864,7 +1845,7 @@
 </file>
 
 <file path=ppt/notesSlides/notesSlide5.xml><?xml version="1.0" encoding="utf-8"?>
-<p:notes xmlns:a="http://schemas.openxmlformats.org/drawingml/2006/main" xmlns:r="http://schemas.openxmlformats.org/officeDocument/2006/relationships" xmlns:p="http://schemas.openxmlformats.org/presentationml/2006/main">
+<p:notes xmlns:a="http://schemas.openxmlformats.org/drawingml/2006/main" xmlns:p="http://schemas.openxmlformats.org/presentationml/2006/main" xmlns:r="http://schemas.openxmlformats.org/officeDocument/2006/relationships">
   <p:cSld>
     <p:spTree>
       <p:nvGrpSpPr>
@@ -1884,7 +1865,7 @@
         <p:nvSpPr>
           <p:cNvPr id="2" name="Slide Image Placeholder 1"/>
           <p:cNvSpPr>
-            <a:spLocks noGrp="1" noRot="1" noChangeAspect="1"/>
+            <a:spLocks noGrp="1"/>
           </p:cNvSpPr>
           <p:nvPr>
             <p:ph type="sldImg" idx="2"/>
@@ -1899,7 +1880,7 @@
             <a:spLocks noGrp="1"/>
           </p:cNvSpPr>
           <p:nvPr>
-            <p:ph type="body" sz="quarter" idx="3"/>
+            <p:ph type="body" idx="3" sz="quarter"/>
           </p:nvPr>
         </p:nvSpPr>
         <p:spPr/>
@@ -1968,7 +1949,7 @@
           </a:p>
           <a:p>
             <a:r>
-              <a:t>UoC/AT1 tie: this is the quality bar for AT1 §9; a recommendation hitting all four is what the</a:t>
+              <a:t>UoC/AT1 tie: this is the quality bar for AT1 §8; a recommendation hitting all four is what the</a:t>
             </a:r>
           </a:p>
           <a:p>
@@ -1985,7 +1966,7 @@
             <a:spLocks noGrp="1"/>
           </p:cNvSpPr>
           <p:nvPr>
-            <p:ph type="sldNum" sz="quarter" idx="5"/>
+            <p:ph type="sldNum" idx="5" sz="quarter"/>
           </p:nvPr>
         </p:nvSpPr>
         <p:spPr/>
@@ -1999,7 +1980,7 @@
 </file>
 
 <file path=ppt/notesSlides/notesSlide6.xml><?xml version="1.0" encoding="utf-8"?>
-<p:notes xmlns:a="http://schemas.openxmlformats.org/drawingml/2006/main" xmlns:r="http://schemas.openxmlformats.org/officeDocument/2006/relationships" xmlns:p="http://schemas.openxmlformats.org/presentationml/2006/main">
+<p:notes xmlns:a="http://schemas.openxmlformats.org/drawingml/2006/main" xmlns:p="http://schemas.openxmlformats.org/presentationml/2006/main" xmlns:r="http://schemas.openxmlformats.org/officeDocument/2006/relationships">
   <p:cSld>
     <p:spTree>
       <p:nvGrpSpPr>
@@ -2019,7 +2000,7 @@
         <p:nvSpPr>
           <p:cNvPr id="2" name="Slide Image Placeholder 1"/>
           <p:cNvSpPr>
-            <a:spLocks noGrp="1" noRot="1" noChangeAspect="1"/>
+            <a:spLocks noGrp="1"/>
           </p:cNvSpPr>
           <p:nvPr>
             <p:ph type="sldImg" idx="2"/>
@@ -2034,7 +2015,7 @@
             <a:spLocks noGrp="1"/>
           </p:cNvSpPr>
           <p:nvPr>
-            <p:ph type="body" sz="quarter" idx="3"/>
+            <p:ph type="body" idx="3" sz="quarter"/>
           </p:nvPr>
         </p:nvSpPr>
         <p:spPr/>
@@ -2043,7 +2024,7 @@
           <a:lstStyle/>
           <a:p>
             <a:r>
-              <a:t>Facilitation — first build task of the Topic. They add §9 to the SAME practice business case they</a:t>
+              <a:t>Facilitation — first build task of the Topic. They add §8 to the SAME practice business case they</a:t>
             </a:r>
           </a:p>
           <a:p>
@@ -2118,7 +2099,7 @@
           </a:p>
           <a:p>
             <a:r>
-              <a:t>No-leakage note: this is PRACTICE on Ledgerline; AT1 assesses the same §9 skill on the LMS —</a:t>
+              <a:t>No-leakage note: this is PRACTICE on Ledgerline; AT1 assesses the same §8 skill on the LMS —</a:t>
             </a:r>
           </a:p>
           <a:p>
@@ -2128,7 +2109,7 @@
           </a:p>
           <a:p>
             <a:r>
-              <a:t>UoC/AT1 tie: PC 2.3 / PE 4 → AT1 Part A §9.</a:t>
+              <a:t>UoC/AT1 tie: PC 2.3 / PE 4 → AT1 Part A §8.</a:t>
             </a:r>
           </a:p>
         </p:txBody>
@@ -2140,7 +2121,7 @@
             <a:spLocks noGrp="1"/>
           </p:cNvSpPr>
           <p:nvPr>
-            <p:ph type="sldNum" sz="quarter" idx="5"/>
+            <p:ph type="sldNum" idx="5" sz="quarter"/>
           </p:nvPr>
         </p:nvSpPr>
         <p:spPr/>
@@ -2154,7 +2135,7 @@
 </file>
 
 <file path=ppt/notesSlides/notesSlide7.xml><?xml version="1.0" encoding="utf-8"?>
-<p:notes xmlns:a="http://schemas.openxmlformats.org/drawingml/2006/main" xmlns:r="http://schemas.openxmlformats.org/officeDocument/2006/relationships" xmlns:p="http://schemas.openxmlformats.org/presentationml/2006/main">
+<p:notes xmlns:a="http://schemas.openxmlformats.org/drawingml/2006/main" xmlns:p="http://schemas.openxmlformats.org/presentationml/2006/main" xmlns:r="http://schemas.openxmlformats.org/officeDocument/2006/relationships">
   <p:cSld>
     <p:spTree>
       <p:nvGrpSpPr>
@@ -2174,7 +2155,7 @@
         <p:nvSpPr>
           <p:cNvPr id="2" name="Slide Image Placeholder 1"/>
           <p:cNvSpPr>
-            <a:spLocks noGrp="1" noRot="1" noChangeAspect="1"/>
+            <a:spLocks noGrp="1"/>
           </p:cNvSpPr>
           <p:nvPr>
             <p:ph type="sldImg" idx="2"/>
@@ -2189,7 +2170,7 @@
             <a:spLocks noGrp="1"/>
           </p:cNvSpPr>
           <p:nvPr>
-            <p:ph type="body" sz="quarter" idx="3"/>
+            <p:ph type="body" idx="3" sz="quarter"/>
           </p:nvPr>
         </p:nvSpPr>
         <p:spPr/>
@@ -2263,7 +2244,7 @@
           </a:p>
           <a:p>
             <a:r>
-              <a:t>UoC/AT1 tie: opens PC 3.1 / 3.2, PE 6, KE 1 → AT1 §10 Action Plan.</a:t>
+              <a:t>UoC/AT1 tie: opens PC 3.1 / 3.2, PE 6, KE 1 → AT1 §9 Action Plan.</a:t>
             </a:r>
           </a:p>
         </p:txBody>
@@ -2275,7 +2256,7 @@
             <a:spLocks noGrp="1"/>
           </p:cNvSpPr>
           <p:nvPr>
-            <p:ph type="sldNum" sz="quarter" idx="5"/>
+            <p:ph type="sldNum" idx="5" sz="quarter"/>
           </p:nvPr>
         </p:nvSpPr>
         <p:spPr/>
@@ -2289,7 +2270,7 @@
 </file>
 
 <file path=ppt/notesSlides/notesSlide8.xml><?xml version="1.0" encoding="utf-8"?>
-<p:notes xmlns:a="http://schemas.openxmlformats.org/drawingml/2006/main" xmlns:r="http://schemas.openxmlformats.org/officeDocument/2006/relationships" xmlns:p="http://schemas.openxmlformats.org/presentationml/2006/main">
+<p:notes xmlns:a="http://schemas.openxmlformats.org/drawingml/2006/main" xmlns:p="http://schemas.openxmlformats.org/presentationml/2006/main" xmlns:r="http://schemas.openxmlformats.org/officeDocument/2006/relationships">
   <p:cSld>
     <p:spTree>
       <p:nvGrpSpPr>
@@ -2309,7 +2290,7 @@
         <p:nvSpPr>
           <p:cNvPr id="2" name="Slide Image Placeholder 1"/>
           <p:cNvSpPr>
-            <a:spLocks noGrp="1" noRot="1" noChangeAspect="1"/>
+            <a:spLocks noGrp="1"/>
           </p:cNvSpPr>
           <p:nvPr>
             <p:ph type="sldImg" idx="2"/>
@@ -2324,7 +2305,7 @@
             <a:spLocks noGrp="1"/>
           </p:cNvSpPr>
           <p:nvPr>
-            <p:ph type="body" sz="quarter" idx="3"/>
+            <p:ph type="body" idx="3" sz="quarter"/>
           </p:nvPr>
         </p:nvSpPr>
         <p:spPr/>
@@ -2333,7 +2314,7 @@
           <a:lstStyle/>
           <a:p>
             <a:r>
-              <a:t>The structural spine of Section 2 — the five parts that BECOME the AT1 §10 Action Plan section.</a:t>
+              <a:t>The structural spine of Section 2 — the five parts that BECOME the AT1 §9 Action Plan section.</a:t>
             </a:r>
           </a:p>
           <a:p>
@@ -2393,7 +2374,7 @@
           </a:p>
           <a:p>
             <a:r>
-              <a:t>UoC/AT1 tie: KE 1 (key sections of an action plan) + PC 3.1 / 3.2, PE 6 → AT1 §10.1–§10.5.</a:t>
+              <a:t>UoC/AT1 tie: KE 1 (key sections of an action plan) + PC 3.1 / 3.2, PE 6 → AT1 §9.1–§9.5.</a:t>
             </a:r>
           </a:p>
         </p:txBody>
@@ -2405,7 +2386,7 @@
             <a:spLocks noGrp="1"/>
           </p:cNvSpPr>
           <p:nvPr>
-            <p:ph type="sldNum" sz="quarter" idx="5"/>
+            <p:ph type="sldNum" idx="5" sz="quarter"/>
           </p:nvPr>
         </p:nvSpPr>
         <p:spPr/>
@@ -2419,7 +2400,7 @@
 </file>
 
 <file path=ppt/notesSlides/notesSlide9.xml><?xml version="1.0" encoding="utf-8"?>
-<p:notes xmlns:a="http://schemas.openxmlformats.org/drawingml/2006/main" xmlns:r="http://schemas.openxmlformats.org/officeDocument/2006/relationships" xmlns:p="http://schemas.openxmlformats.org/presentationml/2006/main">
+<p:notes xmlns:a="http://schemas.openxmlformats.org/drawingml/2006/main" xmlns:p="http://schemas.openxmlformats.org/presentationml/2006/main" xmlns:r="http://schemas.openxmlformats.org/officeDocument/2006/relationships">
   <p:cSld>
     <p:spTree>
       <p:nvGrpSpPr>
@@ -2439,7 +2420,7 @@
         <p:nvSpPr>
           <p:cNvPr id="2" name="Slide Image Placeholder 1"/>
           <p:cNvSpPr>
-            <a:spLocks noGrp="1" noRot="1" noChangeAspect="1"/>
+            <a:spLocks noGrp="1"/>
           </p:cNvSpPr>
           <p:nvPr>
             <p:ph type="sldImg" idx="2"/>
@@ -2454,7 +2435,7 @@
             <a:spLocks noGrp="1"/>
           </p:cNvSpPr>
           <p:nvPr>
-            <p:ph type="body" sz="quarter" idx="3"/>
+            <p:ph type="body" idx="3" sz="quarter"/>
           </p:nvPr>
         </p:nvSpPr>
         <p:spPr/>
@@ -2518,7 +2499,7 @@
           </a:p>
           <a:p>
             <a:r>
-              <a:t>UoC/AT1 tie: PC 3.1 (prioritised schedule consistent with policy/procedures) → AT1 §10.</a:t>
+              <a:t>UoC/AT1 tie: PC 3.1 (prioritised schedule consistent with policy/procedures) → AT1 §9.</a:t>
             </a:r>
           </a:p>
         </p:txBody>
@@ -2530,7 +2511,7 @@
             <a:spLocks noGrp="1"/>
           </p:cNvSpPr>
           <p:nvPr>
-            <p:ph type="sldNum" sz="quarter" idx="5"/>
+            <p:ph type="sldNum" idx="5" sz="quarter"/>
           </p:nvPr>
         </p:nvSpPr>
         <p:spPr/>
@@ -2581,9 +2562,10 @@
           <a:lstStyle/>
           <a:p>
             <a:r>
-              <a:rPr lang="en-US"/>
+              <a:rPr lang="en-US" smtClean="0"/>
               <a:t>Click to edit Master title style</a:t>
             </a:r>
+            <a:endParaRPr lang="en-US"/>
           </a:p>
         </p:txBody>
       </p:sp>
@@ -2699,9 +2681,10 @@
           </a:lstStyle>
           <a:p>
             <a:r>
-              <a:rPr lang="en-US"/>
+              <a:rPr lang="en-US" smtClean="0"/>
               <a:t>Click to edit Master subtitle style</a:t>
             </a:r>
+            <a:endParaRPr lang="en-US"/>
           </a:p>
         </p:txBody>
       </p:sp>
@@ -2722,7 +2705,7 @@
           <a:p>
             <a:fld id="{5BCAD085-E8A6-8845-BD4E-CB4CCA059FC4}" type="datetimeFigureOut">
               <a:rPr lang="en-US" smtClean="0"/>
-              <a:t>7/16/26</a:t>
+              <a:t>1/27/13</a:t>
             </a:fld>
             <a:endParaRPr lang="en-US"/>
           </a:p>
@@ -2816,9 +2799,10 @@
           <a:lstStyle/>
           <a:p>
             <a:r>
-              <a:rPr lang="en-US"/>
+              <a:rPr lang="en-US" smtClean="0"/>
               <a:t>Click to edit Master title style</a:t>
             </a:r>
+            <a:endParaRPr lang="en-US"/>
           </a:p>
         </p:txBody>
       </p:sp>
@@ -2839,37 +2823,38 @@
           <a:p>
             <a:pPr lvl="0"/>
             <a:r>
-              <a:rPr lang="en-US"/>
+              <a:rPr lang="en-US" smtClean="0"/>
               <a:t>Click to edit Master text styles</a:t>
             </a:r>
           </a:p>
           <a:p>
             <a:pPr lvl="1"/>
             <a:r>
-              <a:rPr lang="en-US"/>
+              <a:rPr lang="en-US" smtClean="0"/>
               <a:t>Second level</a:t>
             </a:r>
           </a:p>
           <a:p>
             <a:pPr lvl="2"/>
             <a:r>
-              <a:rPr lang="en-US"/>
+              <a:rPr lang="en-US" smtClean="0"/>
               <a:t>Third level</a:t>
             </a:r>
           </a:p>
           <a:p>
             <a:pPr lvl="3"/>
             <a:r>
-              <a:rPr lang="en-US"/>
+              <a:rPr lang="en-US" smtClean="0"/>
               <a:t>Fourth level</a:t>
             </a:r>
           </a:p>
           <a:p>
             <a:pPr lvl="4"/>
             <a:r>
-              <a:rPr lang="en-US"/>
+              <a:rPr lang="en-US" smtClean="0"/>
               <a:t>Fifth level</a:t>
             </a:r>
+            <a:endParaRPr lang="en-US"/>
           </a:p>
         </p:txBody>
       </p:sp>
@@ -2890,7 +2875,7 @@
           <a:p>
             <a:fld id="{5BCAD085-E8A6-8845-BD4E-CB4CCA059FC4}" type="datetimeFigureOut">
               <a:rPr lang="en-US" smtClean="0"/>
-              <a:t>7/16/26</a:t>
+              <a:t>1/27/13</a:t>
             </a:fld>
             <a:endParaRPr lang="en-US"/>
           </a:p>
@@ -2989,9 +2974,10 @@
           <a:lstStyle/>
           <a:p>
             <a:r>
-              <a:rPr lang="en-US"/>
+              <a:rPr lang="en-US" smtClean="0"/>
               <a:t>Click to edit Master title style</a:t>
             </a:r>
+            <a:endParaRPr lang="en-US"/>
           </a:p>
         </p:txBody>
       </p:sp>
@@ -3017,37 +3003,38 @@
           <a:p>
             <a:pPr lvl="0"/>
             <a:r>
-              <a:rPr lang="en-US"/>
+              <a:rPr lang="en-US" smtClean="0"/>
               <a:t>Click to edit Master text styles</a:t>
             </a:r>
           </a:p>
           <a:p>
             <a:pPr lvl="1"/>
             <a:r>
-              <a:rPr lang="en-US"/>
+              <a:rPr lang="en-US" smtClean="0"/>
               <a:t>Second level</a:t>
             </a:r>
           </a:p>
           <a:p>
             <a:pPr lvl="2"/>
             <a:r>
-              <a:rPr lang="en-US"/>
+              <a:rPr lang="en-US" smtClean="0"/>
               <a:t>Third level</a:t>
             </a:r>
           </a:p>
           <a:p>
             <a:pPr lvl="3"/>
             <a:r>
-              <a:rPr lang="en-US"/>
+              <a:rPr lang="en-US" smtClean="0"/>
               <a:t>Fourth level</a:t>
             </a:r>
           </a:p>
           <a:p>
             <a:pPr lvl="4"/>
             <a:r>
-              <a:rPr lang="en-US"/>
+              <a:rPr lang="en-US" smtClean="0"/>
               <a:t>Fifth level</a:t>
             </a:r>
+            <a:endParaRPr lang="en-US"/>
           </a:p>
         </p:txBody>
       </p:sp>
@@ -3068,7 +3055,7 @@
           <a:p>
             <a:fld id="{5BCAD085-E8A6-8845-BD4E-CB4CCA059FC4}" type="datetimeFigureOut">
               <a:rPr lang="en-US" smtClean="0"/>
-              <a:t>7/16/26</a:t>
+              <a:t>1/27/13</a:t>
             </a:fld>
             <a:endParaRPr lang="en-US"/>
           </a:p>
@@ -3162,9 +3149,10 @@
           <a:lstStyle/>
           <a:p>
             <a:r>
-              <a:rPr lang="en-US"/>
+              <a:rPr lang="en-US" smtClean="0"/>
               <a:t>Click to edit Master title style</a:t>
             </a:r>
+            <a:endParaRPr lang="en-US"/>
           </a:p>
         </p:txBody>
       </p:sp>
@@ -3185,37 +3173,38 @@
           <a:p>
             <a:pPr lvl="0"/>
             <a:r>
-              <a:rPr lang="en-US"/>
+              <a:rPr lang="en-US" smtClean="0"/>
               <a:t>Click to edit Master text styles</a:t>
             </a:r>
           </a:p>
           <a:p>
             <a:pPr lvl="1"/>
             <a:r>
-              <a:rPr lang="en-US"/>
+              <a:rPr lang="en-US" smtClean="0"/>
               <a:t>Second level</a:t>
             </a:r>
           </a:p>
           <a:p>
             <a:pPr lvl="2"/>
             <a:r>
-              <a:rPr lang="en-US"/>
+              <a:rPr lang="en-US" smtClean="0"/>
               <a:t>Third level</a:t>
             </a:r>
           </a:p>
           <a:p>
             <a:pPr lvl="3"/>
             <a:r>
-              <a:rPr lang="en-US"/>
+              <a:rPr lang="en-US" smtClean="0"/>
               <a:t>Fourth level</a:t>
             </a:r>
           </a:p>
           <a:p>
             <a:pPr lvl="4"/>
             <a:r>
-              <a:rPr lang="en-US"/>
+              <a:rPr lang="en-US" smtClean="0"/>
               <a:t>Fifth level</a:t>
             </a:r>
+            <a:endParaRPr lang="en-US"/>
           </a:p>
         </p:txBody>
       </p:sp>
@@ -3236,7 +3225,7 @@
           <a:p>
             <a:fld id="{5BCAD085-E8A6-8845-BD4E-CB4CCA059FC4}" type="datetimeFigureOut">
               <a:rPr lang="en-US" smtClean="0"/>
-              <a:t>7/16/26</a:t>
+              <a:t>1/27/13</a:t>
             </a:fld>
             <a:endParaRPr lang="en-US"/>
           </a:p>
@@ -3339,9 +3328,10 @@
           </a:lstStyle>
           <a:p>
             <a:r>
-              <a:rPr lang="en-US"/>
+              <a:rPr lang="en-US" smtClean="0"/>
               <a:t>Click to edit Master title style</a:t>
             </a:r>
+            <a:endParaRPr lang="en-US"/>
           </a:p>
         </p:txBody>
       </p:sp>
@@ -3458,7 +3448,7 @@
           <a:p>
             <a:pPr lvl="0"/>
             <a:r>
-              <a:rPr lang="en-US"/>
+              <a:rPr lang="en-US" smtClean="0"/>
               <a:t>Click to edit Master text styles</a:t>
             </a:r>
           </a:p>
@@ -3481,7 +3471,7 @@
           <a:p>
             <a:fld id="{5BCAD085-E8A6-8845-BD4E-CB4CCA059FC4}" type="datetimeFigureOut">
               <a:rPr lang="en-US" smtClean="0"/>
-              <a:t>7/16/26</a:t>
+              <a:t>1/27/13</a:t>
             </a:fld>
             <a:endParaRPr lang="en-US"/>
           </a:p>
@@ -3575,9 +3565,10 @@
           <a:lstStyle/>
           <a:p>
             <a:r>
-              <a:rPr lang="en-US"/>
+              <a:rPr lang="en-US" smtClean="0"/>
               <a:t>Click to edit Master title style</a:t>
             </a:r>
+            <a:endParaRPr lang="en-US"/>
           </a:p>
         </p:txBody>
       </p:sp>
@@ -3631,37 +3622,38 @@
           <a:p>
             <a:pPr lvl="0"/>
             <a:r>
-              <a:rPr lang="en-US"/>
+              <a:rPr lang="en-US" smtClean="0"/>
               <a:t>Click to edit Master text styles</a:t>
             </a:r>
           </a:p>
           <a:p>
             <a:pPr lvl="1"/>
             <a:r>
-              <a:rPr lang="en-US"/>
+              <a:rPr lang="en-US" smtClean="0"/>
               <a:t>Second level</a:t>
             </a:r>
           </a:p>
           <a:p>
             <a:pPr lvl="2"/>
             <a:r>
-              <a:rPr lang="en-US"/>
+              <a:rPr lang="en-US" smtClean="0"/>
               <a:t>Third level</a:t>
             </a:r>
           </a:p>
           <a:p>
             <a:pPr lvl="3"/>
             <a:r>
-              <a:rPr lang="en-US"/>
+              <a:rPr lang="en-US" smtClean="0"/>
               <a:t>Fourth level</a:t>
             </a:r>
           </a:p>
           <a:p>
             <a:pPr lvl="4"/>
             <a:r>
-              <a:rPr lang="en-US"/>
+              <a:rPr lang="en-US" smtClean="0"/>
               <a:t>Fifth level</a:t>
             </a:r>
+            <a:endParaRPr lang="en-US"/>
           </a:p>
         </p:txBody>
       </p:sp>
@@ -3715,37 +3707,38 @@
           <a:p>
             <a:pPr lvl="0"/>
             <a:r>
-              <a:rPr lang="en-US"/>
+              <a:rPr lang="en-US" smtClean="0"/>
               <a:t>Click to edit Master text styles</a:t>
             </a:r>
           </a:p>
           <a:p>
             <a:pPr lvl="1"/>
             <a:r>
-              <a:rPr lang="en-US"/>
+              <a:rPr lang="en-US" smtClean="0"/>
               <a:t>Second level</a:t>
             </a:r>
           </a:p>
           <a:p>
             <a:pPr lvl="2"/>
             <a:r>
-              <a:rPr lang="en-US"/>
+              <a:rPr lang="en-US" smtClean="0"/>
               <a:t>Third level</a:t>
             </a:r>
           </a:p>
           <a:p>
             <a:pPr lvl="3"/>
             <a:r>
-              <a:rPr lang="en-US"/>
+              <a:rPr lang="en-US" smtClean="0"/>
               <a:t>Fourth level</a:t>
             </a:r>
           </a:p>
           <a:p>
             <a:pPr lvl="4"/>
             <a:r>
-              <a:rPr lang="en-US"/>
+              <a:rPr lang="en-US" smtClean="0"/>
               <a:t>Fifth level</a:t>
             </a:r>
+            <a:endParaRPr lang="en-US"/>
           </a:p>
         </p:txBody>
       </p:sp>
@@ -3766,7 +3759,7 @@
           <a:p>
             <a:fld id="{5BCAD085-E8A6-8845-BD4E-CB4CCA059FC4}" type="datetimeFigureOut">
               <a:rPr lang="en-US" smtClean="0"/>
-              <a:t>7/16/26</a:t>
+              <a:t>1/27/13</a:t>
             </a:fld>
             <a:endParaRPr lang="en-US"/>
           </a:p>
@@ -3864,9 +3857,10 @@
           </a:lstStyle>
           <a:p>
             <a:r>
-              <a:rPr lang="en-US"/>
+              <a:rPr lang="en-US" smtClean="0"/>
               <a:t>Click to edit Master title style</a:t>
             </a:r>
+            <a:endParaRPr lang="en-US"/>
           </a:p>
         </p:txBody>
       </p:sp>
@@ -3929,7 +3923,7 @@
           <a:p>
             <a:pPr lvl="0"/>
             <a:r>
-              <a:rPr lang="en-US"/>
+              <a:rPr lang="en-US" smtClean="0"/>
               <a:t>Click to edit Master text styles</a:t>
             </a:r>
           </a:p>
@@ -3985,37 +3979,38 @@
           <a:p>
             <a:pPr lvl="0"/>
             <a:r>
-              <a:rPr lang="en-US"/>
+              <a:rPr lang="en-US" smtClean="0"/>
               <a:t>Click to edit Master text styles</a:t>
             </a:r>
           </a:p>
           <a:p>
             <a:pPr lvl="1"/>
             <a:r>
-              <a:rPr lang="en-US"/>
+              <a:rPr lang="en-US" smtClean="0"/>
               <a:t>Second level</a:t>
             </a:r>
           </a:p>
           <a:p>
             <a:pPr lvl="2"/>
             <a:r>
-              <a:rPr lang="en-US"/>
+              <a:rPr lang="en-US" smtClean="0"/>
               <a:t>Third level</a:t>
             </a:r>
           </a:p>
           <a:p>
             <a:pPr lvl="3"/>
             <a:r>
-              <a:rPr lang="en-US"/>
+              <a:rPr lang="en-US" smtClean="0"/>
               <a:t>Fourth level</a:t>
             </a:r>
           </a:p>
           <a:p>
             <a:pPr lvl="4"/>
             <a:r>
-              <a:rPr lang="en-US"/>
+              <a:rPr lang="en-US" smtClean="0"/>
               <a:t>Fifth level</a:t>
             </a:r>
+            <a:endParaRPr lang="en-US"/>
           </a:p>
         </p:txBody>
       </p:sp>
@@ -4078,7 +4073,7 @@
           <a:p>
             <a:pPr lvl="0"/>
             <a:r>
-              <a:rPr lang="en-US"/>
+              <a:rPr lang="en-US" smtClean="0"/>
               <a:t>Click to edit Master text styles</a:t>
             </a:r>
           </a:p>
@@ -4134,37 +4129,38 @@
           <a:p>
             <a:pPr lvl="0"/>
             <a:r>
-              <a:rPr lang="en-US"/>
+              <a:rPr lang="en-US" smtClean="0"/>
               <a:t>Click to edit Master text styles</a:t>
             </a:r>
           </a:p>
           <a:p>
             <a:pPr lvl="1"/>
             <a:r>
-              <a:rPr lang="en-US"/>
+              <a:rPr lang="en-US" smtClean="0"/>
               <a:t>Second level</a:t>
             </a:r>
           </a:p>
           <a:p>
             <a:pPr lvl="2"/>
             <a:r>
-              <a:rPr lang="en-US"/>
+              <a:rPr lang="en-US" smtClean="0"/>
               <a:t>Third level</a:t>
             </a:r>
           </a:p>
           <a:p>
             <a:pPr lvl="3"/>
             <a:r>
-              <a:rPr lang="en-US"/>
+              <a:rPr lang="en-US" smtClean="0"/>
               <a:t>Fourth level</a:t>
             </a:r>
           </a:p>
           <a:p>
             <a:pPr lvl="4"/>
             <a:r>
-              <a:rPr lang="en-US"/>
+              <a:rPr lang="en-US" smtClean="0"/>
               <a:t>Fifth level</a:t>
             </a:r>
+            <a:endParaRPr lang="en-US"/>
           </a:p>
         </p:txBody>
       </p:sp>
@@ -4185,7 +4181,7 @@
           <a:p>
             <a:fld id="{5BCAD085-E8A6-8845-BD4E-CB4CCA059FC4}" type="datetimeFigureOut">
               <a:rPr lang="en-US" smtClean="0"/>
-              <a:t>7/16/26</a:t>
+              <a:t>1/27/13</a:t>
             </a:fld>
             <a:endParaRPr lang="en-US"/>
           </a:p>
@@ -4279,9 +4275,10 @@
           <a:lstStyle/>
           <a:p>
             <a:r>
-              <a:rPr lang="en-US"/>
+              <a:rPr lang="en-US" smtClean="0"/>
               <a:t>Click to edit Master title style</a:t>
             </a:r>
+            <a:endParaRPr lang="en-US"/>
           </a:p>
         </p:txBody>
       </p:sp>
@@ -4302,7 +4299,7 @@
           <a:p>
             <a:fld id="{5BCAD085-E8A6-8845-BD4E-CB4CCA059FC4}" type="datetimeFigureOut">
               <a:rPr lang="en-US" smtClean="0"/>
-              <a:t>7/16/26</a:t>
+              <a:t>1/27/13</a:t>
             </a:fld>
             <a:endParaRPr lang="en-US"/>
           </a:p>
@@ -4397,7 +4394,7 @@
           <a:p>
             <a:fld id="{5BCAD085-E8A6-8845-BD4E-CB4CCA059FC4}" type="datetimeFigureOut">
               <a:rPr lang="en-US" smtClean="0"/>
-              <a:t>7/16/26</a:t>
+              <a:t>1/27/13</a:t>
             </a:fld>
             <a:endParaRPr lang="en-US"/>
           </a:p>
@@ -4500,9 +4497,10 @@
           </a:lstStyle>
           <a:p>
             <a:r>
-              <a:rPr lang="en-US"/>
+              <a:rPr lang="en-US" smtClean="0"/>
               <a:t>Click to edit Master title style</a:t>
             </a:r>
+            <a:endParaRPr lang="en-US"/>
           </a:p>
         </p:txBody>
       </p:sp>
@@ -4556,37 +4554,38 @@
           <a:p>
             <a:pPr lvl="0"/>
             <a:r>
-              <a:rPr lang="en-US"/>
+              <a:rPr lang="en-US" smtClean="0"/>
               <a:t>Click to edit Master text styles</a:t>
             </a:r>
           </a:p>
           <a:p>
             <a:pPr lvl="1"/>
             <a:r>
-              <a:rPr lang="en-US"/>
+              <a:rPr lang="en-US" smtClean="0"/>
               <a:t>Second level</a:t>
             </a:r>
           </a:p>
           <a:p>
             <a:pPr lvl="2"/>
             <a:r>
-              <a:rPr lang="en-US"/>
+              <a:rPr lang="en-US" smtClean="0"/>
               <a:t>Third level</a:t>
             </a:r>
           </a:p>
           <a:p>
             <a:pPr lvl="3"/>
             <a:r>
-              <a:rPr lang="en-US"/>
+              <a:rPr lang="en-US" smtClean="0"/>
               <a:t>Fourth level</a:t>
             </a:r>
           </a:p>
           <a:p>
             <a:pPr lvl="4"/>
             <a:r>
-              <a:rPr lang="en-US"/>
+              <a:rPr lang="en-US" smtClean="0"/>
               <a:t>Fifth level</a:t>
             </a:r>
+            <a:endParaRPr lang="en-US"/>
           </a:p>
         </p:txBody>
       </p:sp>
@@ -4649,7 +4648,7 @@
           <a:p>
             <a:pPr lvl="0"/>
             <a:r>
-              <a:rPr lang="en-US"/>
+              <a:rPr lang="en-US" smtClean="0"/>
               <a:t>Click to edit Master text styles</a:t>
             </a:r>
           </a:p>
@@ -4672,7 +4671,7 @@
           <a:p>
             <a:fld id="{5BCAD085-E8A6-8845-BD4E-CB4CCA059FC4}" type="datetimeFigureOut">
               <a:rPr lang="en-US" smtClean="0"/>
-              <a:t>7/16/26</a:t>
+              <a:t>1/27/13</a:t>
             </a:fld>
             <a:endParaRPr lang="en-US"/>
           </a:p>
@@ -4775,9 +4774,10 @@
           </a:lstStyle>
           <a:p>
             <a:r>
-              <a:rPr lang="en-US"/>
+              <a:rPr lang="en-US" smtClean="0"/>
               <a:t>Click to edit Master title style</a:t>
             </a:r>
+            <a:endParaRPr lang="en-US"/>
           </a:p>
         </p:txBody>
       </p:sp>
@@ -4901,7 +4901,7 @@
           <a:p>
             <a:pPr lvl="0"/>
             <a:r>
-              <a:rPr lang="en-US"/>
+              <a:rPr lang="en-US" smtClean="0"/>
               <a:t>Click to edit Master text styles</a:t>
             </a:r>
           </a:p>
@@ -4924,7 +4924,7 @@
           <a:p>
             <a:fld id="{5BCAD085-E8A6-8845-BD4E-CB4CCA059FC4}" type="datetimeFigureOut">
               <a:rPr lang="en-US" smtClean="0"/>
-              <a:t>7/16/26</a:t>
+              <a:t>1/27/13</a:t>
             </a:fld>
             <a:endParaRPr lang="en-US"/>
           </a:p>
@@ -5033,9 +5033,10 @@
           <a:lstStyle/>
           <a:p>
             <a:r>
-              <a:rPr lang="en-US"/>
+              <a:rPr lang="en-US" smtClean="0"/>
               <a:t>Click to edit Master title style</a:t>
             </a:r>
+            <a:endParaRPr lang="en-US"/>
           </a:p>
         </p:txBody>
       </p:sp>
@@ -5066,37 +5067,38 @@
           <a:p>
             <a:pPr lvl="0"/>
             <a:r>
-              <a:rPr lang="en-US"/>
+              <a:rPr lang="en-US" smtClean="0"/>
               <a:t>Click to edit Master text styles</a:t>
             </a:r>
           </a:p>
           <a:p>
             <a:pPr lvl="1"/>
             <a:r>
-              <a:rPr lang="en-US"/>
+              <a:rPr lang="en-US" smtClean="0"/>
               <a:t>Second level</a:t>
             </a:r>
           </a:p>
           <a:p>
             <a:pPr lvl="2"/>
             <a:r>
-              <a:rPr lang="en-US"/>
+              <a:rPr lang="en-US" smtClean="0"/>
               <a:t>Third level</a:t>
             </a:r>
           </a:p>
           <a:p>
             <a:pPr lvl="3"/>
             <a:r>
-              <a:rPr lang="en-US"/>
+              <a:rPr lang="en-US" smtClean="0"/>
               <a:t>Fourth level</a:t>
             </a:r>
           </a:p>
           <a:p>
             <a:pPr lvl="4"/>
             <a:r>
-              <a:rPr lang="en-US"/>
+              <a:rPr lang="en-US" smtClean="0"/>
               <a:t>Fifth level</a:t>
             </a:r>
+            <a:endParaRPr lang="en-US"/>
           </a:p>
         </p:txBody>
       </p:sp>
@@ -5135,7 +5137,7 @@
           <a:p>
             <a:fld id="{5BCAD085-E8A6-8845-BD4E-CB4CCA059FC4}" type="datetimeFigureOut">
               <a:rPr lang="en-US" smtClean="0"/>
-              <a:t>7/16/26</a:t>
+              <a:t>1/27/13</a:t>
             </a:fld>
             <a:endParaRPr lang="en-US"/>
           </a:p>
@@ -5494,7 +5496,7 @@
 </file>
 
 <file path=ppt/slides/slide1.xml><?xml version="1.0" encoding="utf-8"?>
-<p:sld xmlns:a="http://schemas.openxmlformats.org/drawingml/2006/main" xmlns:r="http://schemas.openxmlformats.org/officeDocument/2006/relationships" xmlns:p="http://schemas.openxmlformats.org/presentationml/2006/main">
+<p:sld xmlns:a="http://schemas.openxmlformats.org/drawingml/2006/main" xmlns:p="http://schemas.openxmlformats.org/presentationml/2006/main" xmlns:r="http://schemas.openxmlformats.org/officeDocument/2006/relationships">
   <p:cSld>
     <p:bg>
       <p:bgPr>
@@ -5510,14 +5512,7 @@
         <p:cNvGrpSpPr/>
         <p:nvPr/>
       </p:nvGrpSpPr>
-      <p:grpSpPr>
-        <a:xfrm>
-          <a:off x="0" y="0"/>
-          <a:ext cx="0" cy="0"/>
-          <a:chOff x="0" y="0"/>
-          <a:chExt cx="0" cy="0"/>
-        </a:xfrm>
-      </p:grpSpPr>
+      <p:grpSpPr/>
       <p:sp>
         <p:nvSpPr>
           <p:cNvPr id="2" name="Rectangle 1"/>
@@ -5559,7 +5554,6 @@
           <a:lstStyle/>
           <a:p>
             <a:pPr algn="ctr"/>
-            <a:endParaRPr/>
           </a:p>
         </p:txBody>
       </p:sp>
@@ -5580,7 +5574,7 @@
           <a:noFill/>
         </p:spPr>
         <p:txBody>
-          <a:bodyPr wrap="square" lIns="0" tIns="0" rIns="0" bIns="0" anchor="t">
+          <a:bodyPr wrap="square" anchor="t" lIns="0" rIns="0" tIns="0" bIns="0">
             <a:spAutoFit/>
           </a:bodyPr>
           <a:lstStyle/>
@@ -5646,7 +5640,7 @@
           <a:noFill/>
         </p:spPr>
         <p:txBody>
-          <a:bodyPr wrap="square" lIns="0" tIns="0" rIns="0" bIns="0" anchor="t">
+          <a:bodyPr wrap="square" anchor="t" lIns="0" rIns="0" tIns="0" bIns="0">
             <a:spAutoFit/>
           </a:bodyPr>
           <a:lstStyle/>
@@ -5681,7 +5675,7 @@
 </file>
 
 <file path=ppt/slides/slide10.xml><?xml version="1.0" encoding="utf-8"?>
-<p:sld xmlns:a="http://schemas.openxmlformats.org/drawingml/2006/main" xmlns:r="http://schemas.openxmlformats.org/officeDocument/2006/relationships" xmlns:p="http://schemas.openxmlformats.org/presentationml/2006/main">
+<p:sld xmlns:a="http://schemas.openxmlformats.org/drawingml/2006/main" xmlns:p="http://schemas.openxmlformats.org/presentationml/2006/main" xmlns:r="http://schemas.openxmlformats.org/officeDocument/2006/relationships">
   <p:cSld>
     <p:bg>
       <p:bgPr>
@@ -5697,14 +5691,7 @@
         <p:cNvGrpSpPr/>
         <p:nvPr/>
       </p:nvGrpSpPr>
-      <p:grpSpPr>
-        <a:xfrm>
-          <a:off x="0" y="0"/>
-          <a:ext cx="0" cy="0"/>
-          <a:chOff x="0" y="0"/>
-          <a:chExt cx="0" cy="0"/>
-        </a:xfrm>
-      </p:grpSpPr>
+      <p:grpSpPr/>
       <p:sp>
         <p:nvSpPr>
           <p:cNvPr id="2" name="Rectangle 1"/>
@@ -5746,7 +5733,6 @@
           <a:lstStyle/>
           <a:p>
             <a:pPr algn="ctr"/>
-            <a:endParaRPr/>
           </a:p>
         </p:txBody>
       </p:sp>
@@ -5767,7 +5753,7 @@
           <a:noFill/>
         </p:spPr>
         <p:txBody>
-          <a:bodyPr wrap="square" lIns="0" tIns="0" rIns="0" bIns="0" anchor="t">
+          <a:bodyPr wrap="square" anchor="t" lIns="0" rIns="0" tIns="0" bIns="0">
             <a:spAutoFit/>
           </a:bodyPr>
           <a:lstStyle/>
@@ -5801,7 +5787,7 @@
           <a:noFill/>
         </p:spPr>
         <p:txBody>
-          <a:bodyPr wrap="square" lIns="0" tIns="0" rIns="0" bIns="0" anchor="t">
+          <a:bodyPr wrap="square" anchor="t" lIns="0" rIns="0" tIns="0" bIns="0">
             <a:spAutoFit/>
           </a:bodyPr>
           <a:lstStyle/>
@@ -5891,7 +5877,6 @@
           <a:lstStyle/>
           <a:p>
             <a:pPr algn="ctr"/>
-            <a:endParaRPr/>
           </a:p>
         </p:txBody>
       </p:sp>
@@ -5912,7 +5897,7 @@
           <a:noFill/>
         </p:spPr>
         <p:txBody>
-          <a:bodyPr wrap="square" lIns="0" tIns="0" rIns="0" bIns="0" anchor="t">
+          <a:bodyPr wrap="square" anchor="t" lIns="0" rIns="0" tIns="0" bIns="0">
             <a:spAutoFit/>
           </a:bodyPr>
           <a:lstStyle/>
@@ -5955,13 +5940,21 @@
           <a:noFill/>
         </p:spPr>
         <p:txBody>
-          <a:bodyPr wrap="square" lIns="0" tIns="0" rIns="0" bIns="0" anchor="t">
+          <a:bodyPr wrap="square" anchor="t" lIns="0" rIns="0" tIns="0" bIns="0">
             <a:spAutoFit/>
           </a:bodyPr>
           <a:lstStyle/>
           <a:p>
             <a:pPr algn="r"/>
-            <a:endParaRPr/>
+            <a:r>
+              <a:rPr sz="1100" b="0" i="0">
+                <a:solidFill>
+                  <a:srgbClr val="7A7A7A"/>
+                </a:solidFill>
+                <a:latin typeface="Roboto"/>
+              </a:rPr>
+              <a:t/>
+            </a:r>
           </a:p>
         </p:txBody>
       </p:sp>
@@ -5974,7 +5967,7 @@
 </file>
 
 <file path=ppt/slides/slide11.xml><?xml version="1.0" encoding="utf-8"?>
-<p:sld xmlns:a="http://schemas.openxmlformats.org/drawingml/2006/main" xmlns:r="http://schemas.openxmlformats.org/officeDocument/2006/relationships" xmlns:p="http://schemas.openxmlformats.org/presentationml/2006/main">
+<p:sld xmlns:a="http://schemas.openxmlformats.org/drawingml/2006/main" xmlns:p="http://schemas.openxmlformats.org/presentationml/2006/main" xmlns:r="http://schemas.openxmlformats.org/officeDocument/2006/relationships">
   <p:cSld>
     <p:bg>
       <p:bgPr>
@@ -5990,14 +5983,7 @@
         <p:cNvGrpSpPr/>
         <p:nvPr/>
       </p:nvGrpSpPr>
-      <p:grpSpPr>
-        <a:xfrm>
-          <a:off x="0" y="0"/>
-          <a:ext cx="0" cy="0"/>
-          <a:chOff x="0" y="0"/>
-          <a:chExt cx="0" cy="0"/>
-        </a:xfrm>
-      </p:grpSpPr>
+      <p:grpSpPr/>
       <p:sp>
         <p:nvSpPr>
           <p:cNvPr id="2" name="TextBox 1"/>
@@ -6015,7 +6001,7 @@
           <a:noFill/>
         </p:spPr>
         <p:txBody>
-          <a:bodyPr wrap="square" lIns="0" tIns="0" rIns="0" bIns="0" anchor="t">
+          <a:bodyPr wrap="square" anchor="t" lIns="0" rIns="0" tIns="0" bIns="0">
             <a:spAutoFit/>
           </a:bodyPr>
           <a:lstStyle/>
@@ -6073,7 +6059,6 @@
           <a:lstStyle/>
           <a:p>
             <a:pPr algn="ctr"/>
-            <a:endParaRPr/>
           </a:p>
         </p:txBody>
       </p:sp>
@@ -6094,7 +6079,7 @@
           <a:noFill/>
         </p:spPr>
         <p:txBody>
-          <a:bodyPr wrap="square" lIns="0" tIns="0" rIns="0" bIns="0" anchor="ctr">
+          <a:bodyPr wrap="square" anchor="ctr" lIns="0" rIns="0" tIns="0" bIns="0">
             <a:spAutoFit/>
           </a:bodyPr>
           <a:lstStyle/>
@@ -6234,7 +6219,6 @@
           <a:lstStyle/>
           <a:p>
             <a:pPr algn="ctr"/>
-            <a:endParaRPr/>
           </a:p>
         </p:txBody>
       </p:sp>
@@ -6255,7 +6239,7 @@
           <a:noFill/>
         </p:spPr>
         <p:txBody>
-          <a:bodyPr wrap="square" lIns="0" tIns="0" rIns="0" bIns="0" anchor="t">
+          <a:bodyPr wrap="square" anchor="t" lIns="0" rIns="0" tIns="0" bIns="0">
             <a:spAutoFit/>
           </a:bodyPr>
           <a:lstStyle/>
@@ -6298,7 +6282,7 @@
           <a:noFill/>
         </p:spPr>
         <p:txBody>
-          <a:bodyPr wrap="square" lIns="0" tIns="0" rIns="0" bIns="0" anchor="t">
+          <a:bodyPr wrap="square" anchor="t" lIns="0" rIns="0" tIns="0" bIns="0">
             <a:spAutoFit/>
           </a:bodyPr>
           <a:lstStyle/>
@@ -6325,7 +6309,7 @@
 </file>
 
 <file path=ppt/slides/slide12.xml><?xml version="1.0" encoding="utf-8"?>
-<p:sld xmlns:a="http://schemas.openxmlformats.org/drawingml/2006/main" xmlns:r="http://schemas.openxmlformats.org/officeDocument/2006/relationships" xmlns:p="http://schemas.openxmlformats.org/presentationml/2006/main">
+<p:sld xmlns:a="http://schemas.openxmlformats.org/drawingml/2006/main" xmlns:p="http://schemas.openxmlformats.org/presentationml/2006/main" xmlns:r="http://schemas.openxmlformats.org/officeDocument/2006/relationships">
   <p:cSld>
     <p:bg>
       <p:bgPr>
@@ -6341,14 +6325,7 @@
         <p:cNvGrpSpPr/>
         <p:nvPr/>
       </p:nvGrpSpPr>
-      <p:grpSpPr>
-        <a:xfrm>
-          <a:off x="0" y="0"/>
-          <a:ext cx="0" cy="0"/>
-          <a:chOff x="0" y="0"/>
-          <a:chExt cx="0" cy="0"/>
-        </a:xfrm>
-      </p:grpSpPr>
+      <p:grpSpPr/>
       <p:sp>
         <p:nvSpPr>
           <p:cNvPr id="2" name="TextBox 1"/>
@@ -6366,7 +6343,7 @@
           <a:noFill/>
         </p:spPr>
         <p:txBody>
-          <a:bodyPr wrap="square" lIns="0" tIns="0" rIns="0" bIns="0" anchor="t">
+          <a:bodyPr wrap="square" anchor="t" lIns="0" rIns="0" tIns="0" bIns="0">
             <a:spAutoFit/>
           </a:bodyPr>
           <a:lstStyle/>
@@ -6440,7 +6417,6 @@
           <a:lstStyle/>
           <a:p>
             <a:pPr algn="ctr"/>
-            <a:endParaRPr/>
           </a:p>
         </p:txBody>
       </p:sp>
@@ -6461,7 +6437,7 @@
           <a:noFill/>
         </p:spPr>
         <p:txBody>
-          <a:bodyPr wrap="square" lIns="0" tIns="0" rIns="0" bIns="0" anchor="ctr">
+          <a:bodyPr wrap="square" anchor="ctr" lIns="0" rIns="0" tIns="0" bIns="0">
             <a:spAutoFit/>
           </a:bodyPr>
           <a:lstStyle/>
@@ -6663,7 +6639,6 @@
           <a:lstStyle/>
           <a:p>
             <a:pPr algn="ctr"/>
-            <a:endParaRPr/>
           </a:p>
         </p:txBody>
       </p:sp>
@@ -6684,7 +6659,7 @@
           <a:noFill/>
         </p:spPr>
         <p:txBody>
-          <a:bodyPr wrap="square" lIns="0" tIns="0" rIns="0" bIns="0" anchor="t">
+          <a:bodyPr wrap="square" anchor="t" lIns="0" rIns="0" tIns="0" bIns="0">
             <a:spAutoFit/>
           </a:bodyPr>
           <a:lstStyle/>
@@ -6727,7 +6702,7 @@
           <a:noFill/>
         </p:spPr>
         <p:txBody>
-          <a:bodyPr wrap="square" lIns="0" tIns="0" rIns="0" bIns="0" anchor="t">
+          <a:bodyPr wrap="square" anchor="t" lIns="0" rIns="0" tIns="0" bIns="0">
             <a:spAutoFit/>
           </a:bodyPr>
           <a:lstStyle/>
@@ -6754,7 +6729,7 @@
 </file>
 
 <file path=ppt/slides/slide13.xml><?xml version="1.0" encoding="utf-8"?>
-<p:sld xmlns:a="http://schemas.openxmlformats.org/drawingml/2006/main" xmlns:r="http://schemas.openxmlformats.org/officeDocument/2006/relationships" xmlns:p="http://schemas.openxmlformats.org/presentationml/2006/main">
+<p:sld xmlns:a="http://schemas.openxmlformats.org/drawingml/2006/main" xmlns:p="http://schemas.openxmlformats.org/presentationml/2006/main" xmlns:r="http://schemas.openxmlformats.org/officeDocument/2006/relationships">
   <p:cSld>
     <p:bg>
       <p:bgPr>
@@ -6770,14 +6745,7 @@
         <p:cNvGrpSpPr/>
         <p:nvPr/>
       </p:nvGrpSpPr>
-      <p:grpSpPr>
-        <a:xfrm>
-          <a:off x="0" y="0"/>
-          <a:ext cx="0" cy="0"/>
-          <a:chOff x="0" y="0"/>
-          <a:chExt cx="0" cy="0"/>
-        </a:xfrm>
-      </p:grpSpPr>
+      <p:grpSpPr/>
       <p:sp>
         <p:nvSpPr>
           <p:cNvPr id="2" name="TextBox 1"/>
@@ -6795,7 +6763,7 @@
           <a:noFill/>
         </p:spPr>
         <p:txBody>
-          <a:bodyPr wrap="square" lIns="0" tIns="0" rIns="0" bIns="0" anchor="t">
+          <a:bodyPr wrap="square" anchor="t" lIns="0" rIns="0" tIns="0" bIns="0">
             <a:spAutoFit/>
           </a:bodyPr>
           <a:lstStyle/>
@@ -6853,7 +6821,6 @@
           <a:lstStyle/>
           <a:p>
             <a:pPr algn="ctr"/>
-            <a:endParaRPr/>
           </a:p>
         </p:txBody>
       </p:sp>
@@ -6874,7 +6841,7 @@
           <a:noFill/>
         </p:spPr>
         <p:txBody>
-          <a:bodyPr wrap="square" lIns="0" tIns="0" rIns="0" bIns="0" anchor="ctr">
+          <a:bodyPr wrap="square" anchor="ctr" lIns="0" rIns="0" tIns="0" bIns="0">
             <a:spAutoFit/>
           </a:bodyPr>
           <a:lstStyle/>
@@ -7014,7 +6981,6 @@
           <a:lstStyle/>
           <a:p>
             <a:pPr algn="ctr"/>
-            <a:endParaRPr/>
           </a:p>
         </p:txBody>
       </p:sp>
@@ -7035,7 +7001,7 @@
           <a:noFill/>
         </p:spPr>
         <p:txBody>
-          <a:bodyPr wrap="square" lIns="0" tIns="0" rIns="0" bIns="0" anchor="t">
+          <a:bodyPr wrap="square" anchor="t" lIns="0" rIns="0" tIns="0" bIns="0">
             <a:spAutoFit/>
           </a:bodyPr>
           <a:lstStyle/>
@@ -7078,7 +7044,7 @@
           <a:noFill/>
         </p:spPr>
         <p:txBody>
-          <a:bodyPr wrap="square" lIns="0" tIns="0" rIns="0" bIns="0" anchor="t">
+          <a:bodyPr wrap="square" anchor="t" lIns="0" rIns="0" tIns="0" bIns="0">
             <a:spAutoFit/>
           </a:bodyPr>
           <a:lstStyle/>
@@ -7105,7 +7071,7 @@
 </file>
 
 <file path=ppt/slides/slide14.xml><?xml version="1.0" encoding="utf-8"?>
-<p:sld xmlns:a="http://schemas.openxmlformats.org/drawingml/2006/main" xmlns:r="http://schemas.openxmlformats.org/officeDocument/2006/relationships" xmlns:p="http://schemas.openxmlformats.org/presentationml/2006/main">
+<p:sld xmlns:a="http://schemas.openxmlformats.org/drawingml/2006/main" xmlns:p="http://schemas.openxmlformats.org/presentationml/2006/main" xmlns:r="http://schemas.openxmlformats.org/officeDocument/2006/relationships">
   <p:cSld>
     <p:bg>
       <p:bgPr>
@@ -7121,14 +7087,7 @@
         <p:cNvGrpSpPr/>
         <p:nvPr/>
       </p:nvGrpSpPr>
-      <p:grpSpPr>
-        <a:xfrm>
-          <a:off x="0" y="0"/>
-          <a:ext cx="0" cy="0"/>
-          <a:chOff x="0" y="0"/>
-          <a:chExt cx="0" cy="0"/>
-        </a:xfrm>
-      </p:grpSpPr>
+      <p:grpSpPr/>
       <p:sp>
         <p:nvSpPr>
           <p:cNvPr id="2" name="TextBox 1"/>
@@ -7146,7 +7105,7 @@
           <a:noFill/>
         </p:spPr>
         <p:txBody>
-          <a:bodyPr wrap="square" lIns="0" tIns="0" rIns="0" bIns="0" anchor="t">
+          <a:bodyPr wrap="square" anchor="t" lIns="0" rIns="0" tIns="0" bIns="0">
             <a:spAutoFit/>
           </a:bodyPr>
           <a:lstStyle/>
@@ -7204,7 +7163,6 @@
           <a:lstStyle/>
           <a:p>
             <a:pPr algn="ctr"/>
-            <a:endParaRPr/>
           </a:p>
         </p:txBody>
       </p:sp>
@@ -7225,7 +7183,7 @@
           <a:noFill/>
         </p:spPr>
         <p:txBody>
-          <a:bodyPr wrap="square" lIns="0" tIns="0" rIns="0" bIns="0" anchor="ctr">
+          <a:bodyPr wrap="square" anchor="ctr" lIns="0" rIns="0" tIns="0" bIns="0">
             <a:spAutoFit/>
           </a:bodyPr>
           <a:lstStyle/>
@@ -7365,7 +7323,6 @@
           <a:lstStyle/>
           <a:p>
             <a:pPr algn="ctr"/>
-            <a:endParaRPr/>
           </a:p>
         </p:txBody>
       </p:sp>
@@ -7386,7 +7343,7 @@
           <a:noFill/>
         </p:spPr>
         <p:txBody>
-          <a:bodyPr wrap="square" lIns="0" tIns="0" rIns="0" bIns="0" anchor="t">
+          <a:bodyPr wrap="square" anchor="t" lIns="0" rIns="0" tIns="0" bIns="0">
             <a:spAutoFit/>
           </a:bodyPr>
           <a:lstStyle/>
@@ -7429,7 +7386,7 @@
           <a:noFill/>
         </p:spPr>
         <p:txBody>
-          <a:bodyPr wrap="square" lIns="0" tIns="0" rIns="0" bIns="0" anchor="t">
+          <a:bodyPr wrap="square" anchor="t" lIns="0" rIns="0" tIns="0" bIns="0">
             <a:spAutoFit/>
           </a:bodyPr>
           <a:lstStyle/>
@@ -7456,7 +7413,7 @@
 </file>
 
 <file path=ppt/slides/slide15.xml><?xml version="1.0" encoding="utf-8"?>
-<p:sld xmlns:a="http://schemas.openxmlformats.org/drawingml/2006/main" xmlns:r="http://schemas.openxmlformats.org/officeDocument/2006/relationships" xmlns:p="http://schemas.openxmlformats.org/presentationml/2006/main">
+<p:sld xmlns:a="http://schemas.openxmlformats.org/drawingml/2006/main" xmlns:p="http://schemas.openxmlformats.org/presentationml/2006/main" xmlns:r="http://schemas.openxmlformats.org/officeDocument/2006/relationships">
   <p:cSld>
     <p:bg>
       <p:bgPr>
@@ -7472,14 +7429,7 @@
         <p:cNvGrpSpPr/>
         <p:nvPr/>
       </p:nvGrpSpPr>
-      <p:grpSpPr>
-        <a:xfrm>
-          <a:off x="0" y="0"/>
-          <a:ext cx="0" cy="0"/>
-          <a:chOff x="0" y="0"/>
-          <a:chExt cx="0" cy="0"/>
-        </a:xfrm>
-      </p:grpSpPr>
+      <p:grpSpPr/>
       <p:sp>
         <p:nvSpPr>
           <p:cNvPr id="2" name="TextBox 1"/>
@@ -7497,7 +7447,7 @@
           <a:noFill/>
         </p:spPr>
         <p:txBody>
-          <a:bodyPr wrap="square" lIns="0" tIns="0" rIns="0" bIns="0" anchor="t">
+          <a:bodyPr wrap="square" anchor="t" lIns="0" rIns="0" tIns="0" bIns="0">
             <a:spAutoFit/>
           </a:bodyPr>
           <a:lstStyle/>
@@ -7555,7 +7505,6 @@
           <a:lstStyle/>
           <a:p>
             <a:pPr algn="ctr"/>
-            <a:endParaRPr/>
           </a:p>
         </p:txBody>
       </p:sp>
@@ -7576,7 +7525,7 @@
           <a:noFill/>
         </p:spPr>
         <p:txBody>
-          <a:bodyPr wrap="square" lIns="0" tIns="0" rIns="0" bIns="0" anchor="ctr">
+          <a:bodyPr wrap="square" anchor="ctr" lIns="0" rIns="0" tIns="0" bIns="0">
             <a:spAutoFit/>
           </a:bodyPr>
           <a:lstStyle/>
@@ -7747,7 +7696,6 @@
           <a:lstStyle/>
           <a:p>
             <a:pPr algn="ctr"/>
-            <a:endParaRPr/>
           </a:p>
         </p:txBody>
       </p:sp>
@@ -7768,7 +7716,7 @@
           <a:noFill/>
         </p:spPr>
         <p:txBody>
-          <a:bodyPr wrap="square" lIns="0" tIns="0" rIns="0" bIns="0" anchor="t">
+          <a:bodyPr wrap="square" anchor="t" lIns="0" rIns="0" tIns="0" bIns="0">
             <a:spAutoFit/>
           </a:bodyPr>
           <a:lstStyle/>
@@ -7811,7 +7759,7 @@
           <a:noFill/>
         </p:spPr>
         <p:txBody>
-          <a:bodyPr wrap="square" lIns="0" tIns="0" rIns="0" bIns="0" anchor="t">
+          <a:bodyPr wrap="square" anchor="t" lIns="0" rIns="0" tIns="0" bIns="0">
             <a:spAutoFit/>
           </a:bodyPr>
           <a:lstStyle/>
@@ -7838,7 +7786,7 @@
 </file>
 
 <file path=ppt/slides/slide16.xml><?xml version="1.0" encoding="utf-8"?>
-<p:sld xmlns:a="http://schemas.openxmlformats.org/drawingml/2006/main" xmlns:r="http://schemas.openxmlformats.org/officeDocument/2006/relationships" xmlns:p="http://schemas.openxmlformats.org/presentationml/2006/main">
+<p:sld xmlns:a="http://schemas.openxmlformats.org/drawingml/2006/main" xmlns:p="http://schemas.openxmlformats.org/presentationml/2006/main" xmlns:r="http://schemas.openxmlformats.org/officeDocument/2006/relationships">
   <p:cSld>
     <p:bg>
       <p:bgPr>
@@ -7854,14 +7802,7 @@
         <p:cNvGrpSpPr/>
         <p:nvPr/>
       </p:nvGrpSpPr>
-      <p:grpSpPr>
-        <a:xfrm>
-          <a:off x="0" y="0"/>
-          <a:ext cx="0" cy="0"/>
-          <a:chOff x="0" y="0"/>
-          <a:chExt cx="0" cy="0"/>
-        </a:xfrm>
-      </p:grpSpPr>
+      <p:grpSpPr/>
       <p:sp>
         <p:nvSpPr>
           <p:cNvPr id="2" name="Rectangle 1"/>
@@ -7903,7 +7844,6 @@
           <a:lstStyle/>
           <a:p>
             <a:pPr algn="ctr"/>
-            <a:endParaRPr/>
           </a:p>
         </p:txBody>
       </p:sp>
@@ -7977,7 +7917,7 @@
           <a:noFill/>
         </p:spPr>
         <p:txBody>
-          <a:bodyPr wrap="square" lIns="0" tIns="0" rIns="0" bIns="0" anchor="ctr">
+          <a:bodyPr wrap="square" anchor="ctr" lIns="0" rIns="0" tIns="0" bIns="0">
             <a:spAutoFit/>
           </a:bodyPr>
           <a:lstStyle/>
@@ -8003,7 +7943,7 @@
         <p:spPr>
           <a:xfrm>
             <a:off x="658368" y="1554480"/>
-            <a:ext cx="10881360" cy="3472938"/>
+            <a:ext cx="10881360" cy="4297680"/>
           </a:xfrm>
           <a:prstGeom prst="rect">
             <a:avLst/>
@@ -8011,7 +7951,7 @@
           <a:noFill/>
         </p:spPr>
         <p:txBody>
-          <a:bodyPr wrap="square" lIns="0" tIns="0" rIns="0" bIns="0" anchor="t">
+          <a:bodyPr wrap="square" anchor="t" lIns="0" rIns="0" tIns="0" bIns="0">
             <a:spAutoFit/>
           </a:bodyPr>
           <a:lstStyle/>
@@ -8028,7 +7968,7 @@
               </a:spcAft>
             </a:pPr>
             <a:r>
-              <a:rPr sz="2400" b="1" i="0" dirty="0">
+              <a:rPr sz="1700" b="1" i="0">
                 <a:solidFill>
                   <a:srgbClr val="EDAB0C"/>
                 </a:solidFill>
@@ -8037,7 +7977,7 @@
               <a:t>■  </a:t>
             </a:r>
             <a:r>
-              <a:rPr sz="2400" b="0" i="0" dirty="0">
+              <a:rPr sz="1700" b="0" i="0">
                 <a:solidFill>
                   <a:srgbClr val="2A2929"/>
                 </a:solidFill>
@@ -8059,7 +7999,7 @@
               </a:spcAft>
             </a:pPr>
             <a:r>
-              <a:rPr sz="2400" b="1" i="0" dirty="0">
+              <a:rPr sz="1700" b="1" i="0">
                 <a:solidFill>
                   <a:srgbClr val="EDAB0C"/>
                 </a:solidFill>
@@ -8068,7 +8008,7 @@
               <a:t>■  </a:t>
             </a:r>
             <a:r>
-              <a:rPr sz="2400" b="0" i="0" dirty="0">
+              <a:rPr sz="1700" b="0" i="0">
                 <a:solidFill>
                   <a:srgbClr val="2A2929"/>
                 </a:solidFill>
@@ -8090,7 +8030,7 @@
               </a:spcAft>
             </a:pPr>
             <a:r>
-              <a:rPr sz="2000" b="0" i="0" dirty="0">
+              <a:rPr sz="1400" b="0" i="0">
                 <a:solidFill>
                   <a:srgbClr val="7A7A7A"/>
                 </a:solidFill>
@@ -8099,22 +8039,13 @@
               <a:t>–  </a:t>
             </a:r>
             <a:r>
-              <a:rPr sz="2000" b="0" i="0" dirty="0" err="1">
+              <a:rPr sz="1400" b="0" i="0">
                 <a:solidFill>
                   <a:srgbClr val="2A2929"/>
                 </a:solidFill>
                 <a:latin typeface="Roboto"/>
               </a:rPr>
-              <a:t>prioritised</a:t>
-            </a:r>
-            <a:r>
-              <a:rPr sz="2000" b="0" i="0" dirty="0">
-                <a:solidFill>
-                  <a:srgbClr val="2A2929"/>
-                </a:solidFill>
-                <a:latin typeface="Roboto"/>
-              </a:rPr>
-              <a:t> changes · implementation schedule (phases)</a:t>
+              <a:t>prioritised changes · implementation schedule (phases)</a:t>
             </a:r>
           </a:p>
           <a:p>
@@ -8130,7 +8061,7 @@
               </a:spcAft>
             </a:pPr>
             <a:r>
-              <a:rPr sz="2000" b="0" i="0" dirty="0">
+              <a:rPr sz="1400" b="0" i="0">
                 <a:solidFill>
                   <a:srgbClr val="7A7A7A"/>
                 </a:solidFill>
@@ -8139,7 +8070,7 @@
               <a:t>–  </a:t>
             </a:r>
             <a:r>
-              <a:rPr sz="2000" b="0" i="0" dirty="0">
+              <a:rPr sz="1400" b="0" i="0">
                 <a:solidFill>
                   <a:srgbClr val="2A2929"/>
                 </a:solidFill>
@@ -8161,7 +8092,7 @@
               </a:spcAft>
             </a:pPr>
             <a:r>
-              <a:rPr sz="2000" b="0" i="0" dirty="0">
+              <a:rPr sz="1400" b="0" i="0">
                 <a:solidFill>
                   <a:srgbClr val="7A7A7A"/>
                 </a:solidFill>
@@ -8170,7 +8101,7 @@
               <a:t>–  </a:t>
             </a:r>
             <a:r>
-              <a:rPr sz="2000" b="0" i="0" dirty="0">
+              <a:rPr sz="1400" b="0" i="0">
                 <a:solidFill>
                   <a:srgbClr val="2A2929"/>
                 </a:solidFill>
@@ -8192,7 +8123,7 @@
               </a:spcAft>
             </a:pPr>
             <a:r>
-              <a:rPr sz="2400" b="1" i="0" dirty="0">
+              <a:rPr sz="1700" b="1" i="0">
                 <a:solidFill>
                   <a:srgbClr val="EDAB0C"/>
                 </a:solidFill>
@@ -8201,7 +8132,7 @@
               <a:t>■  </a:t>
             </a:r>
             <a:r>
-              <a:rPr sz="2400" b="0" i="0" dirty="0">
+              <a:rPr sz="1700" b="0" i="0">
                 <a:solidFill>
                   <a:srgbClr val="2A2929"/>
                 </a:solidFill>
@@ -8223,7 +8154,7 @@
               </a:spcAft>
             </a:pPr>
             <a:r>
-              <a:rPr sz="2400" b="1" i="0" dirty="0">
+              <a:rPr sz="1700" b="1" i="0">
                 <a:solidFill>
                   <a:srgbClr val="EDAB0C"/>
                 </a:solidFill>
@@ -8232,7 +8163,7 @@
               <a:t>■  </a:t>
             </a:r>
             <a:r>
-              <a:rPr sz="2400" b="0" i="0" dirty="0">
+              <a:rPr sz="1700" b="0" i="0">
                 <a:solidFill>
                   <a:srgbClr val="2A2929"/>
                 </a:solidFill>
@@ -8286,7 +8217,6 @@
           <a:lstStyle/>
           <a:p>
             <a:pPr algn="ctr"/>
-            <a:endParaRPr/>
           </a:p>
         </p:txBody>
       </p:sp>
@@ -8307,7 +8237,7 @@
           <a:noFill/>
         </p:spPr>
         <p:txBody>
-          <a:bodyPr wrap="square" lIns="0" tIns="0" rIns="0" bIns="0" anchor="ctr">
+          <a:bodyPr wrap="square" anchor="ctr" lIns="0" rIns="0" tIns="0" bIns="0">
             <a:spAutoFit/>
           </a:bodyPr>
           <a:lstStyle/>
@@ -8365,7 +8295,6 @@
           <a:lstStyle/>
           <a:p>
             <a:pPr algn="ctr"/>
-            <a:endParaRPr/>
           </a:p>
         </p:txBody>
       </p:sp>
@@ -8386,7 +8315,7 @@
           <a:noFill/>
         </p:spPr>
         <p:txBody>
-          <a:bodyPr wrap="square" lIns="0" tIns="0" rIns="0" bIns="0" anchor="t">
+          <a:bodyPr wrap="square" anchor="t" lIns="0" rIns="0" tIns="0" bIns="0">
             <a:spAutoFit/>
           </a:bodyPr>
           <a:lstStyle/>
@@ -8429,7 +8358,7 @@
           <a:noFill/>
         </p:spPr>
         <p:txBody>
-          <a:bodyPr wrap="square" lIns="0" tIns="0" rIns="0" bIns="0" anchor="t">
+          <a:bodyPr wrap="square" anchor="t" lIns="0" rIns="0" tIns="0" bIns="0">
             <a:spAutoFit/>
           </a:bodyPr>
           <a:lstStyle/>
@@ -8456,7 +8385,7 @@
 </file>
 
 <file path=ppt/slides/slide17.xml><?xml version="1.0" encoding="utf-8"?>
-<p:sld xmlns:a="http://schemas.openxmlformats.org/drawingml/2006/main" xmlns:r="http://schemas.openxmlformats.org/officeDocument/2006/relationships" xmlns:p="http://schemas.openxmlformats.org/presentationml/2006/main">
+<p:sld xmlns:a="http://schemas.openxmlformats.org/drawingml/2006/main" xmlns:p="http://schemas.openxmlformats.org/presentationml/2006/main" xmlns:r="http://schemas.openxmlformats.org/officeDocument/2006/relationships">
   <p:cSld>
     <p:bg>
       <p:bgPr>
@@ -8472,14 +8401,7 @@
         <p:cNvGrpSpPr/>
         <p:nvPr/>
       </p:nvGrpSpPr>
-      <p:grpSpPr>
-        <a:xfrm>
-          <a:off x="0" y="0"/>
-          <a:ext cx="0" cy="0"/>
-          <a:chOff x="0" y="0"/>
-          <a:chExt cx="0" cy="0"/>
-        </a:xfrm>
-      </p:grpSpPr>
+      <p:grpSpPr/>
       <p:sp>
         <p:nvSpPr>
           <p:cNvPr id="2" name="TextBox 1"/>
@@ -8497,7 +8419,7 @@
           <a:noFill/>
         </p:spPr>
         <p:txBody>
-          <a:bodyPr wrap="square" lIns="0" tIns="0" rIns="0" bIns="0" anchor="t">
+          <a:bodyPr wrap="square" anchor="t" lIns="0" rIns="0" tIns="0" bIns="0">
             <a:spAutoFit/>
           </a:bodyPr>
           <a:lstStyle/>
@@ -8571,7 +8493,6 @@
           <a:lstStyle/>
           <a:p>
             <a:pPr algn="ctr"/>
-            <a:endParaRPr/>
           </a:p>
         </p:txBody>
       </p:sp>
@@ -8618,7 +8539,6 @@
           <a:lstStyle/>
           <a:p>
             <a:pPr algn="ctr"/>
-            <a:endParaRPr/>
           </a:p>
         </p:txBody>
       </p:sp>
@@ -8663,7 +8583,6 @@
           <a:lstStyle/>
           <a:p>
             <a:pPr algn="ctr"/>
-            <a:endParaRPr/>
           </a:p>
         </p:txBody>
       </p:sp>
@@ -8684,7 +8603,7 @@
           <a:noFill/>
         </p:spPr>
         <p:txBody>
-          <a:bodyPr wrap="square" lIns="0" tIns="0" rIns="0" bIns="0" anchor="ctr">
+          <a:bodyPr wrap="square" anchor="ctr" lIns="0" rIns="0" tIns="0" bIns="0">
             <a:spAutoFit/>
           </a:bodyPr>
           <a:lstStyle/>
@@ -8749,7 +8668,6 @@
           <a:lstStyle/>
           <a:p>
             <a:pPr algn="ctr"/>
-            <a:endParaRPr/>
           </a:p>
         </p:txBody>
       </p:sp>
@@ -8794,7 +8712,6 @@
           <a:lstStyle/>
           <a:p>
             <a:pPr algn="ctr"/>
-            <a:endParaRPr/>
           </a:p>
         </p:txBody>
       </p:sp>
@@ -8815,7 +8732,7 @@
           <a:noFill/>
         </p:spPr>
         <p:txBody>
-          <a:bodyPr wrap="square" lIns="0" tIns="0" rIns="0" bIns="0" anchor="ctr">
+          <a:bodyPr wrap="square" anchor="ctr" lIns="0" rIns="0" tIns="0" bIns="0">
             <a:spAutoFit/>
           </a:bodyPr>
           <a:lstStyle/>
@@ -8880,7 +8797,6 @@
           <a:lstStyle/>
           <a:p>
             <a:pPr algn="ctr"/>
-            <a:endParaRPr/>
           </a:p>
         </p:txBody>
       </p:sp>
@@ -8925,7 +8841,6 @@
           <a:lstStyle/>
           <a:p>
             <a:pPr algn="ctr"/>
-            <a:endParaRPr/>
           </a:p>
         </p:txBody>
       </p:sp>
@@ -8946,7 +8861,7 @@
           <a:noFill/>
         </p:spPr>
         <p:txBody>
-          <a:bodyPr wrap="square" lIns="0" tIns="0" rIns="0" bIns="0" anchor="ctr">
+          <a:bodyPr wrap="square" anchor="ctr" lIns="0" rIns="0" tIns="0" bIns="0">
             <a:spAutoFit/>
           </a:bodyPr>
           <a:lstStyle/>
@@ -9009,7 +8924,6 @@
           <a:lstStyle/>
           <a:p>
             <a:pPr algn="ctr"/>
-            <a:endParaRPr/>
           </a:p>
         </p:txBody>
       </p:sp>
@@ -9030,7 +8944,7 @@
           <a:noFill/>
         </p:spPr>
         <p:txBody>
-          <a:bodyPr wrap="square" lIns="0" tIns="0" rIns="0" bIns="0" anchor="t">
+          <a:bodyPr wrap="square" anchor="t" lIns="0" rIns="0" tIns="0" bIns="0">
             <a:spAutoFit/>
           </a:bodyPr>
           <a:lstStyle/>
@@ -9073,7 +8987,7 @@
           <a:noFill/>
         </p:spPr>
         <p:txBody>
-          <a:bodyPr wrap="square" lIns="0" tIns="0" rIns="0" bIns="0" anchor="t">
+          <a:bodyPr wrap="square" anchor="t" lIns="0" rIns="0" tIns="0" bIns="0">
             <a:spAutoFit/>
           </a:bodyPr>
           <a:lstStyle/>
@@ -9100,7 +9014,7 @@
 </file>
 
 <file path=ppt/slides/slide18.xml><?xml version="1.0" encoding="utf-8"?>
-<p:sld xmlns:a="http://schemas.openxmlformats.org/drawingml/2006/main" xmlns:r="http://schemas.openxmlformats.org/officeDocument/2006/relationships" xmlns:p="http://schemas.openxmlformats.org/presentationml/2006/main">
+<p:sld xmlns:a="http://schemas.openxmlformats.org/drawingml/2006/main" xmlns:p="http://schemas.openxmlformats.org/presentationml/2006/main" xmlns:r="http://schemas.openxmlformats.org/officeDocument/2006/relationships">
   <p:cSld>
     <p:bg>
       <p:bgPr>
@@ -9116,14 +9030,7 @@
         <p:cNvGrpSpPr/>
         <p:nvPr/>
       </p:nvGrpSpPr>
-      <p:grpSpPr>
-        <a:xfrm>
-          <a:off x="0" y="0"/>
-          <a:ext cx="0" cy="0"/>
-          <a:chOff x="0" y="0"/>
-          <a:chExt cx="0" cy="0"/>
-        </a:xfrm>
-      </p:grpSpPr>
+      <p:grpSpPr/>
       <p:sp>
         <p:nvSpPr>
           <p:cNvPr id="2" name="Rectangle 1"/>
@@ -9165,7 +9072,6 @@
           <a:lstStyle/>
           <a:p>
             <a:pPr algn="ctr"/>
-            <a:endParaRPr/>
           </a:p>
         </p:txBody>
       </p:sp>
@@ -9186,7 +9092,7 @@
           <a:noFill/>
         </p:spPr>
         <p:txBody>
-          <a:bodyPr wrap="square" lIns="0" tIns="0" rIns="0" bIns="0" anchor="t">
+          <a:bodyPr wrap="square" anchor="t" lIns="0" rIns="0" tIns="0" bIns="0">
             <a:spAutoFit/>
           </a:bodyPr>
           <a:lstStyle/>
@@ -9220,7 +9126,7 @@
           <a:noFill/>
         </p:spPr>
         <p:txBody>
-          <a:bodyPr wrap="square" lIns="0" tIns="0" rIns="0" bIns="0" anchor="t">
+          <a:bodyPr wrap="square" anchor="t" lIns="0" rIns="0" tIns="0" bIns="0">
             <a:spAutoFit/>
           </a:bodyPr>
           <a:lstStyle/>
@@ -9310,7 +9216,6 @@
           <a:lstStyle/>
           <a:p>
             <a:pPr algn="ctr"/>
-            <a:endParaRPr/>
           </a:p>
         </p:txBody>
       </p:sp>
@@ -9331,7 +9236,7 @@
           <a:noFill/>
         </p:spPr>
         <p:txBody>
-          <a:bodyPr wrap="square" lIns="0" tIns="0" rIns="0" bIns="0" anchor="t">
+          <a:bodyPr wrap="square" anchor="t" lIns="0" rIns="0" tIns="0" bIns="0">
             <a:spAutoFit/>
           </a:bodyPr>
           <a:lstStyle/>
@@ -9374,13 +9279,21 @@
           <a:noFill/>
         </p:spPr>
         <p:txBody>
-          <a:bodyPr wrap="square" lIns="0" tIns="0" rIns="0" bIns="0" anchor="t">
+          <a:bodyPr wrap="square" anchor="t" lIns="0" rIns="0" tIns="0" bIns="0">
             <a:spAutoFit/>
           </a:bodyPr>
           <a:lstStyle/>
           <a:p>
             <a:pPr algn="r"/>
-            <a:endParaRPr/>
+            <a:r>
+              <a:rPr sz="1100" b="0" i="0">
+                <a:solidFill>
+                  <a:srgbClr val="7A7A7A"/>
+                </a:solidFill>
+                <a:latin typeface="Roboto"/>
+              </a:rPr>
+              <a:t/>
+            </a:r>
           </a:p>
         </p:txBody>
       </p:sp>
@@ -9393,7 +9306,7 @@
 </file>
 
 <file path=ppt/slides/slide19.xml><?xml version="1.0" encoding="utf-8"?>
-<p:sld xmlns:a="http://schemas.openxmlformats.org/drawingml/2006/main" xmlns:r="http://schemas.openxmlformats.org/officeDocument/2006/relationships" xmlns:p="http://schemas.openxmlformats.org/presentationml/2006/main">
+<p:sld xmlns:a="http://schemas.openxmlformats.org/drawingml/2006/main" xmlns:p="http://schemas.openxmlformats.org/presentationml/2006/main" xmlns:r="http://schemas.openxmlformats.org/officeDocument/2006/relationships">
   <p:cSld>
     <p:bg>
       <p:bgPr>
@@ -9409,14 +9322,7 @@
         <p:cNvGrpSpPr/>
         <p:nvPr/>
       </p:nvGrpSpPr>
-      <p:grpSpPr>
-        <a:xfrm>
-          <a:off x="0" y="0"/>
-          <a:ext cx="0" cy="0"/>
-          <a:chOff x="0" y="0"/>
-          <a:chExt cx="0" cy="0"/>
-        </a:xfrm>
-      </p:grpSpPr>
+      <p:grpSpPr/>
       <p:sp>
         <p:nvSpPr>
           <p:cNvPr id="2" name="TextBox 1"/>
@@ -9434,7 +9340,7 @@
           <a:noFill/>
         </p:spPr>
         <p:txBody>
-          <a:bodyPr wrap="square" lIns="0" tIns="0" rIns="0" bIns="0" anchor="t">
+          <a:bodyPr wrap="square" anchor="t" lIns="0" rIns="0" tIns="0" bIns="0">
             <a:spAutoFit/>
           </a:bodyPr>
           <a:lstStyle/>
@@ -9492,7 +9398,6 @@
           <a:lstStyle/>
           <a:p>
             <a:pPr algn="ctr"/>
-            <a:endParaRPr/>
           </a:p>
         </p:txBody>
       </p:sp>
@@ -9513,7 +9418,7 @@
           <a:noFill/>
         </p:spPr>
         <p:txBody>
-          <a:bodyPr wrap="square" lIns="0" tIns="0" rIns="0" bIns="0" anchor="ctr">
+          <a:bodyPr wrap="square" anchor="ctr" lIns="0" rIns="0" tIns="0" bIns="0">
             <a:spAutoFit/>
           </a:bodyPr>
           <a:lstStyle/>
@@ -9622,7 +9527,6 @@
           <a:lstStyle/>
           <a:p>
             <a:pPr algn="ctr"/>
-            <a:endParaRPr/>
           </a:p>
         </p:txBody>
       </p:sp>
@@ -9643,7 +9547,7 @@
           <a:noFill/>
         </p:spPr>
         <p:txBody>
-          <a:bodyPr wrap="square" lIns="0" tIns="0" rIns="0" bIns="0" anchor="t">
+          <a:bodyPr wrap="square" anchor="t" lIns="0" rIns="0" tIns="0" bIns="0">
             <a:spAutoFit/>
           </a:bodyPr>
           <a:lstStyle/>
@@ -9686,7 +9590,7 @@
           <a:noFill/>
         </p:spPr>
         <p:txBody>
-          <a:bodyPr wrap="square" lIns="0" tIns="0" rIns="0" bIns="0" anchor="t">
+          <a:bodyPr wrap="square" anchor="t" lIns="0" rIns="0" tIns="0" bIns="0">
             <a:spAutoFit/>
           </a:bodyPr>
           <a:lstStyle/>
@@ -9713,7 +9617,7 @@
 </file>
 
 <file path=ppt/slides/slide2.xml><?xml version="1.0" encoding="utf-8"?>
-<p:sld xmlns:a="http://schemas.openxmlformats.org/drawingml/2006/main" xmlns:r="http://schemas.openxmlformats.org/officeDocument/2006/relationships" xmlns:p="http://schemas.openxmlformats.org/presentationml/2006/main">
+<p:sld xmlns:a="http://schemas.openxmlformats.org/drawingml/2006/main" xmlns:p="http://schemas.openxmlformats.org/presentationml/2006/main" xmlns:r="http://schemas.openxmlformats.org/officeDocument/2006/relationships">
   <p:cSld>
     <p:bg>
       <p:bgPr>
@@ -9729,14 +9633,7 @@
         <p:cNvGrpSpPr/>
         <p:nvPr/>
       </p:nvGrpSpPr>
-      <p:grpSpPr>
-        <a:xfrm>
-          <a:off x="0" y="0"/>
-          <a:ext cx="0" cy="0"/>
-          <a:chOff x="0" y="0"/>
-          <a:chExt cx="0" cy="0"/>
-        </a:xfrm>
-      </p:grpSpPr>
+      <p:grpSpPr/>
       <p:sp>
         <p:nvSpPr>
           <p:cNvPr id="2" name="TextBox 1"/>
@@ -9754,7 +9651,7 @@
           <a:noFill/>
         </p:spPr>
         <p:txBody>
-          <a:bodyPr wrap="square" lIns="0" tIns="0" rIns="0" bIns="0" anchor="t">
+          <a:bodyPr wrap="square" anchor="t" lIns="0" rIns="0" tIns="0" bIns="0">
             <a:spAutoFit/>
           </a:bodyPr>
           <a:lstStyle/>
@@ -9828,7 +9725,6 @@
           <a:lstStyle/>
           <a:p>
             <a:pPr algn="ctr"/>
-            <a:endParaRPr/>
           </a:p>
         </p:txBody>
       </p:sp>
@@ -9849,7 +9745,7 @@
           <a:noFill/>
         </p:spPr>
         <p:txBody>
-          <a:bodyPr wrap="square" lIns="0" tIns="0" rIns="0" bIns="0" anchor="ctr">
+          <a:bodyPr wrap="square" anchor="ctr" lIns="0" rIns="0" tIns="0" bIns="0">
             <a:spAutoFit/>
           </a:bodyPr>
           <a:lstStyle/>
@@ -10020,7 +9916,6 @@
           <a:lstStyle/>
           <a:p>
             <a:pPr algn="ctr"/>
-            <a:endParaRPr/>
           </a:p>
         </p:txBody>
       </p:sp>
@@ -10041,7 +9936,7 @@
           <a:noFill/>
         </p:spPr>
         <p:txBody>
-          <a:bodyPr wrap="square" lIns="0" tIns="0" rIns="0" bIns="0" anchor="t">
+          <a:bodyPr wrap="square" anchor="t" lIns="0" rIns="0" tIns="0" bIns="0">
             <a:spAutoFit/>
           </a:bodyPr>
           <a:lstStyle/>
@@ -10084,7 +9979,7 @@
           <a:noFill/>
         </p:spPr>
         <p:txBody>
-          <a:bodyPr wrap="square" lIns="0" tIns="0" rIns="0" bIns="0" anchor="t">
+          <a:bodyPr wrap="square" anchor="t" lIns="0" rIns="0" tIns="0" bIns="0">
             <a:spAutoFit/>
           </a:bodyPr>
           <a:lstStyle/>
@@ -10111,7 +10006,7 @@
 </file>
 
 <file path=ppt/slides/slide20.xml><?xml version="1.0" encoding="utf-8"?>
-<p:sld xmlns:a="http://schemas.openxmlformats.org/drawingml/2006/main" xmlns:r="http://schemas.openxmlformats.org/officeDocument/2006/relationships" xmlns:p="http://schemas.openxmlformats.org/presentationml/2006/main">
+<p:sld xmlns:a="http://schemas.openxmlformats.org/drawingml/2006/main" xmlns:p="http://schemas.openxmlformats.org/presentationml/2006/main" xmlns:r="http://schemas.openxmlformats.org/officeDocument/2006/relationships">
   <p:cSld>
     <p:bg>
       <p:bgPr>
@@ -10127,14 +10022,7 @@
         <p:cNvGrpSpPr/>
         <p:nvPr/>
       </p:nvGrpSpPr>
-      <p:grpSpPr>
-        <a:xfrm>
-          <a:off x="0" y="0"/>
-          <a:ext cx="0" cy="0"/>
-          <a:chOff x="0" y="0"/>
-          <a:chExt cx="0" cy="0"/>
-        </a:xfrm>
-      </p:grpSpPr>
+      <p:grpSpPr/>
       <p:sp>
         <p:nvSpPr>
           <p:cNvPr id="2" name="TextBox 1"/>
@@ -10152,7 +10040,7 @@
           <a:noFill/>
         </p:spPr>
         <p:txBody>
-          <a:bodyPr wrap="square" lIns="0" tIns="0" rIns="0" bIns="0" anchor="t">
+          <a:bodyPr wrap="square" anchor="t" lIns="0" rIns="0" tIns="0" bIns="0">
             <a:spAutoFit/>
           </a:bodyPr>
           <a:lstStyle/>
@@ -10226,7 +10114,6 @@
           <a:lstStyle/>
           <a:p>
             <a:pPr algn="ctr"/>
-            <a:endParaRPr/>
           </a:p>
         </p:txBody>
       </p:sp>
@@ -10247,7 +10134,7 @@
           <a:noFill/>
         </p:spPr>
         <p:txBody>
-          <a:bodyPr wrap="square" lIns="0" tIns="0" rIns="0" bIns="0" anchor="ctr">
+          <a:bodyPr wrap="square" anchor="ctr" lIns="0" rIns="0" tIns="0" bIns="0">
             <a:spAutoFit/>
           </a:bodyPr>
           <a:lstStyle/>
@@ -10449,7 +10336,6 @@
           <a:lstStyle/>
           <a:p>
             <a:pPr algn="ctr"/>
-            <a:endParaRPr/>
           </a:p>
         </p:txBody>
       </p:sp>
@@ -10470,7 +10356,7 @@
           <a:noFill/>
         </p:spPr>
         <p:txBody>
-          <a:bodyPr wrap="square" lIns="0" tIns="0" rIns="0" bIns="0" anchor="t">
+          <a:bodyPr wrap="square" anchor="t" lIns="0" rIns="0" tIns="0" bIns="0">
             <a:spAutoFit/>
           </a:bodyPr>
           <a:lstStyle/>
@@ -10513,7 +10399,7 @@
           <a:noFill/>
         </p:spPr>
         <p:txBody>
-          <a:bodyPr wrap="square" lIns="0" tIns="0" rIns="0" bIns="0" anchor="t">
+          <a:bodyPr wrap="square" anchor="t" lIns="0" rIns="0" tIns="0" bIns="0">
             <a:spAutoFit/>
           </a:bodyPr>
           <a:lstStyle/>
@@ -10540,7 +10426,7 @@
 </file>
 
 <file path=ppt/slides/slide21.xml><?xml version="1.0" encoding="utf-8"?>
-<p:sld xmlns:a="http://schemas.openxmlformats.org/drawingml/2006/main" xmlns:r="http://schemas.openxmlformats.org/officeDocument/2006/relationships" xmlns:p="http://schemas.openxmlformats.org/presentationml/2006/main">
+<p:sld xmlns:a="http://schemas.openxmlformats.org/drawingml/2006/main" xmlns:p="http://schemas.openxmlformats.org/presentationml/2006/main" xmlns:r="http://schemas.openxmlformats.org/officeDocument/2006/relationships">
   <p:cSld>
     <p:bg>
       <p:bgPr>
@@ -10556,14 +10442,7 @@
         <p:cNvGrpSpPr/>
         <p:nvPr/>
       </p:nvGrpSpPr>
-      <p:grpSpPr>
-        <a:xfrm>
-          <a:off x="0" y="0"/>
-          <a:ext cx="0" cy="0"/>
-          <a:chOff x="0" y="0"/>
-          <a:chExt cx="0" cy="0"/>
-        </a:xfrm>
-      </p:grpSpPr>
+      <p:grpSpPr/>
       <p:sp>
         <p:nvSpPr>
           <p:cNvPr id="2" name="Rectangle 1"/>
@@ -10605,7 +10484,6 @@
           <a:lstStyle/>
           <a:p>
             <a:pPr algn="ctr"/>
-            <a:endParaRPr/>
           </a:p>
         </p:txBody>
       </p:sp>
@@ -10679,7 +10557,7 @@
           <a:noFill/>
         </p:spPr>
         <p:txBody>
-          <a:bodyPr wrap="square" lIns="0" tIns="0" rIns="0" bIns="0" anchor="ctr">
+          <a:bodyPr wrap="square" anchor="ctr" lIns="0" rIns="0" tIns="0" bIns="0">
             <a:spAutoFit/>
           </a:bodyPr>
           <a:lstStyle/>
@@ -10705,7 +10583,7 @@
         <p:spPr>
           <a:xfrm>
             <a:off x="658368" y="1554480"/>
-            <a:ext cx="10881360" cy="3054939"/>
+            <a:ext cx="10881360" cy="4297680"/>
           </a:xfrm>
           <a:prstGeom prst="rect">
             <a:avLst/>
@@ -10713,7 +10591,7 @@
           <a:noFill/>
         </p:spPr>
         <p:txBody>
-          <a:bodyPr wrap="square" lIns="0" tIns="0" rIns="0" bIns="0" anchor="t">
+          <a:bodyPr wrap="square" anchor="t" lIns="0" rIns="0" tIns="0" bIns="0">
             <a:spAutoFit/>
           </a:bodyPr>
           <a:lstStyle/>
@@ -10730,7 +10608,7 @@
               </a:spcAft>
             </a:pPr>
             <a:r>
-              <a:rPr sz="2000" b="1" i="0" dirty="0">
+              <a:rPr sz="1700" b="1" i="0">
                 <a:solidFill>
                   <a:srgbClr val="EDAB0C"/>
                 </a:solidFill>
@@ -10739,7 +10617,7 @@
               <a:t>■  </a:t>
             </a:r>
             <a:r>
-              <a:rPr sz="2000" b="0" i="0" dirty="0">
+              <a:rPr sz="1700" b="0" i="0">
                 <a:solidFill>
                   <a:srgbClr val="2A2929"/>
                 </a:solidFill>
@@ -10761,7 +10639,7 @@
               </a:spcAft>
             </a:pPr>
             <a:r>
-              <a:rPr sz="2000" b="1" i="0" dirty="0">
+              <a:rPr sz="1700" b="1" i="0">
                 <a:solidFill>
                   <a:srgbClr val="EDAB0C"/>
                 </a:solidFill>
@@ -10770,7 +10648,7 @@
               <a:t>■  </a:t>
             </a:r>
             <a:r>
-              <a:rPr sz="2000" b="0" i="0" dirty="0">
+              <a:rPr sz="1700" b="0" i="0">
                 <a:solidFill>
                   <a:srgbClr val="2A2929"/>
                 </a:solidFill>
@@ -10792,7 +10670,7 @@
               </a:spcAft>
             </a:pPr>
             <a:r>
-              <a:rPr b="0" i="0" dirty="0">
+              <a:rPr sz="1400" b="0" i="0">
                 <a:solidFill>
                   <a:srgbClr val="7A7A7A"/>
                 </a:solidFill>
@@ -10801,7 +10679,7 @@
               <a:t>–  </a:t>
             </a:r>
             <a:r>
-              <a:rPr b="0" i="0" dirty="0">
+              <a:rPr sz="1400" b="0" i="0">
                 <a:solidFill>
                   <a:srgbClr val="2A2929"/>
                 </a:solidFill>
@@ -10823,7 +10701,7 @@
               </a:spcAft>
             </a:pPr>
             <a:r>
-              <a:rPr b="0" i="0" dirty="0">
+              <a:rPr sz="1400" b="0" i="0">
                 <a:solidFill>
                   <a:srgbClr val="7A7A7A"/>
                 </a:solidFill>
@@ -10832,7 +10710,7 @@
               <a:t>–  </a:t>
             </a:r>
             <a:r>
-              <a:rPr b="0" i="0" dirty="0">
+              <a:rPr sz="1400" b="0" i="0">
                 <a:solidFill>
                   <a:srgbClr val="2A2929"/>
                 </a:solidFill>
@@ -10854,7 +10732,7 @@
               </a:spcAft>
             </a:pPr>
             <a:r>
-              <a:rPr b="0" i="0" dirty="0">
+              <a:rPr sz="1400" b="0" i="0">
                 <a:solidFill>
                   <a:srgbClr val="7A7A7A"/>
                 </a:solidFill>
@@ -10863,7 +10741,7 @@
               <a:t>–  </a:t>
             </a:r>
             <a:r>
-              <a:rPr b="0" i="0" dirty="0">
+              <a:rPr sz="1400" b="0" i="0">
                 <a:solidFill>
                   <a:srgbClr val="2A2929"/>
                 </a:solidFill>
@@ -10885,7 +10763,7 @@
               </a:spcAft>
             </a:pPr>
             <a:r>
-              <a:rPr sz="2000" b="1" i="0" dirty="0">
+              <a:rPr sz="1700" b="1" i="0">
                 <a:solidFill>
                   <a:srgbClr val="EDAB0C"/>
                 </a:solidFill>
@@ -10894,7 +10772,7 @@
               <a:t>■  </a:t>
             </a:r>
             <a:r>
-              <a:rPr sz="2000" b="0" i="0" dirty="0">
+              <a:rPr sz="1700" b="0" i="0">
                 <a:solidFill>
                   <a:srgbClr val="2A2929"/>
                 </a:solidFill>
@@ -10916,7 +10794,7 @@
               </a:spcAft>
             </a:pPr>
             <a:r>
-              <a:rPr sz="2000" b="1" i="0" dirty="0">
+              <a:rPr sz="1700" b="1" i="0">
                 <a:solidFill>
                   <a:srgbClr val="EDAB0C"/>
                 </a:solidFill>
@@ -10925,7 +10803,7 @@
               <a:t>■  </a:t>
             </a:r>
             <a:r>
-              <a:rPr sz="2000" b="0" i="0" dirty="0">
+              <a:rPr sz="1700" b="0" i="0">
                 <a:solidFill>
                   <a:srgbClr val="2A2929"/>
                 </a:solidFill>
@@ -10979,7 +10857,6 @@
           <a:lstStyle/>
           <a:p>
             <a:pPr algn="ctr"/>
-            <a:endParaRPr/>
           </a:p>
         </p:txBody>
       </p:sp>
@@ -11000,7 +10877,7 @@
           <a:noFill/>
         </p:spPr>
         <p:txBody>
-          <a:bodyPr wrap="square" lIns="0" tIns="0" rIns="0" bIns="0" anchor="ctr">
+          <a:bodyPr wrap="square" anchor="ctr" lIns="0" rIns="0" tIns="0" bIns="0">
             <a:spAutoFit/>
           </a:bodyPr>
           <a:lstStyle/>
@@ -11058,7 +10935,6 @@
           <a:lstStyle/>
           <a:p>
             <a:pPr algn="ctr"/>
-            <a:endParaRPr/>
           </a:p>
         </p:txBody>
       </p:sp>
@@ -11079,7 +10955,7 @@
           <a:noFill/>
         </p:spPr>
         <p:txBody>
-          <a:bodyPr wrap="square" lIns="0" tIns="0" rIns="0" bIns="0" anchor="t">
+          <a:bodyPr wrap="square" anchor="t" lIns="0" rIns="0" tIns="0" bIns="0">
             <a:spAutoFit/>
           </a:bodyPr>
           <a:lstStyle/>
@@ -11122,7 +10998,7 @@
           <a:noFill/>
         </p:spPr>
         <p:txBody>
-          <a:bodyPr wrap="square" lIns="0" tIns="0" rIns="0" bIns="0" anchor="t">
+          <a:bodyPr wrap="square" anchor="t" lIns="0" rIns="0" tIns="0" bIns="0">
             <a:spAutoFit/>
           </a:bodyPr>
           <a:lstStyle/>
@@ -11149,7 +11025,7 @@
 </file>
 
 <file path=ppt/slides/slide22.xml><?xml version="1.0" encoding="utf-8"?>
-<p:sld xmlns:a="http://schemas.openxmlformats.org/drawingml/2006/main" xmlns:r="http://schemas.openxmlformats.org/officeDocument/2006/relationships" xmlns:p="http://schemas.openxmlformats.org/presentationml/2006/main">
+<p:sld xmlns:a="http://schemas.openxmlformats.org/drawingml/2006/main" xmlns:p="http://schemas.openxmlformats.org/presentationml/2006/main" xmlns:r="http://schemas.openxmlformats.org/officeDocument/2006/relationships">
   <p:cSld>
     <p:bg>
       <p:bgPr>
@@ -11165,14 +11041,7 @@
         <p:cNvGrpSpPr/>
         <p:nvPr/>
       </p:nvGrpSpPr>
-      <p:grpSpPr>
-        <a:xfrm>
-          <a:off x="0" y="0"/>
-          <a:ext cx="0" cy="0"/>
-          <a:chOff x="0" y="0"/>
-          <a:chExt cx="0" cy="0"/>
-        </a:xfrm>
-      </p:grpSpPr>
+      <p:grpSpPr/>
       <p:sp>
         <p:nvSpPr>
           <p:cNvPr id="2" name="TextBox 1"/>
@@ -11190,7 +11059,7 @@
           <a:noFill/>
         </p:spPr>
         <p:txBody>
-          <a:bodyPr wrap="square" lIns="0" tIns="0" rIns="0" bIns="0" anchor="t">
+          <a:bodyPr wrap="square" anchor="t" lIns="0" rIns="0" tIns="0" bIns="0">
             <a:spAutoFit/>
           </a:bodyPr>
           <a:lstStyle/>
@@ -11264,7 +11133,6 @@
           <a:lstStyle/>
           <a:p>
             <a:pPr algn="ctr"/>
-            <a:endParaRPr/>
           </a:p>
         </p:txBody>
       </p:sp>
@@ -11311,7 +11179,6 @@
           <a:lstStyle/>
           <a:p>
             <a:pPr algn="ctr"/>
-            <a:endParaRPr/>
           </a:p>
         </p:txBody>
       </p:sp>
@@ -11356,7 +11223,6 @@
           <a:lstStyle/>
           <a:p>
             <a:pPr algn="ctr"/>
-            <a:endParaRPr/>
           </a:p>
         </p:txBody>
       </p:sp>
@@ -11377,7 +11243,7 @@
           <a:noFill/>
         </p:spPr>
         <p:txBody>
-          <a:bodyPr wrap="square" lIns="0" tIns="0" rIns="0" bIns="0" anchor="ctr">
+          <a:bodyPr wrap="square" anchor="ctr" lIns="0" rIns="0" tIns="0" bIns="0">
             <a:spAutoFit/>
           </a:bodyPr>
           <a:lstStyle/>
@@ -11442,7 +11308,6 @@
           <a:lstStyle/>
           <a:p>
             <a:pPr algn="ctr"/>
-            <a:endParaRPr/>
           </a:p>
         </p:txBody>
       </p:sp>
@@ -11487,7 +11352,6 @@
           <a:lstStyle/>
           <a:p>
             <a:pPr algn="ctr"/>
-            <a:endParaRPr/>
           </a:p>
         </p:txBody>
       </p:sp>
@@ -11508,7 +11372,7 @@
           <a:noFill/>
         </p:spPr>
         <p:txBody>
-          <a:bodyPr wrap="square" lIns="0" tIns="0" rIns="0" bIns="0" anchor="ctr">
+          <a:bodyPr wrap="square" anchor="ctr" lIns="0" rIns="0" tIns="0" bIns="0">
             <a:spAutoFit/>
           </a:bodyPr>
           <a:lstStyle/>
@@ -11573,7 +11437,6 @@
           <a:lstStyle/>
           <a:p>
             <a:pPr algn="ctr"/>
-            <a:endParaRPr/>
           </a:p>
         </p:txBody>
       </p:sp>
@@ -11618,7 +11481,6 @@
           <a:lstStyle/>
           <a:p>
             <a:pPr algn="ctr"/>
-            <a:endParaRPr/>
           </a:p>
         </p:txBody>
       </p:sp>
@@ -11639,7 +11501,7 @@
           <a:noFill/>
         </p:spPr>
         <p:txBody>
-          <a:bodyPr wrap="square" lIns="0" tIns="0" rIns="0" bIns="0" anchor="ctr">
+          <a:bodyPr wrap="square" anchor="ctr" lIns="0" rIns="0" tIns="0" bIns="0">
             <a:spAutoFit/>
           </a:bodyPr>
           <a:lstStyle/>
@@ -11702,7 +11564,6 @@
           <a:lstStyle/>
           <a:p>
             <a:pPr algn="ctr"/>
-            <a:endParaRPr/>
           </a:p>
         </p:txBody>
       </p:sp>
@@ -11723,7 +11584,7 @@
           <a:noFill/>
         </p:spPr>
         <p:txBody>
-          <a:bodyPr wrap="square" lIns="0" tIns="0" rIns="0" bIns="0" anchor="t">
+          <a:bodyPr wrap="square" anchor="t" lIns="0" rIns="0" tIns="0" bIns="0">
             <a:spAutoFit/>
           </a:bodyPr>
           <a:lstStyle/>
@@ -11766,7 +11627,7 @@
           <a:noFill/>
         </p:spPr>
         <p:txBody>
-          <a:bodyPr wrap="square" lIns="0" tIns="0" rIns="0" bIns="0" anchor="t">
+          <a:bodyPr wrap="square" anchor="t" lIns="0" rIns="0" tIns="0" bIns="0">
             <a:spAutoFit/>
           </a:bodyPr>
           <a:lstStyle/>
@@ -11793,7 +11654,7 @@
 </file>
 
 <file path=ppt/slides/slide23.xml><?xml version="1.0" encoding="utf-8"?>
-<p:sld xmlns:a="http://schemas.openxmlformats.org/drawingml/2006/main" xmlns:r="http://schemas.openxmlformats.org/officeDocument/2006/relationships" xmlns:p="http://schemas.openxmlformats.org/presentationml/2006/main">
+<p:sld xmlns:a="http://schemas.openxmlformats.org/drawingml/2006/main" xmlns:p="http://schemas.openxmlformats.org/presentationml/2006/main" xmlns:r="http://schemas.openxmlformats.org/officeDocument/2006/relationships">
   <p:cSld>
     <p:bg>
       <p:bgPr>
@@ -11809,14 +11670,7 @@
         <p:cNvGrpSpPr/>
         <p:nvPr/>
       </p:nvGrpSpPr>
-      <p:grpSpPr>
-        <a:xfrm>
-          <a:off x="0" y="0"/>
-          <a:ext cx="0" cy="0"/>
-          <a:chOff x="0" y="0"/>
-          <a:chExt cx="0" cy="0"/>
-        </a:xfrm>
-      </p:grpSpPr>
+      <p:grpSpPr/>
       <p:sp>
         <p:nvSpPr>
           <p:cNvPr id="2" name="Rectangle 1"/>
@@ -11858,7 +11712,6 @@
           <a:lstStyle/>
           <a:p>
             <a:pPr algn="ctr"/>
-            <a:endParaRPr/>
           </a:p>
         </p:txBody>
       </p:sp>
@@ -11879,7 +11732,7 @@
           <a:noFill/>
         </p:spPr>
         <p:txBody>
-          <a:bodyPr wrap="square" lIns="0" tIns="0" rIns="0" bIns="0" anchor="t">
+          <a:bodyPr wrap="square" anchor="t" lIns="0" rIns="0" tIns="0" bIns="0">
             <a:spAutoFit/>
           </a:bodyPr>
           <a:lstStyle/>
@@ -11981,7 +11834,7 @@
 </file>
 
 <file path=ppt/slides/slide3.xml><?xml version="1.0" encoding="utf-8"?>
-<p:sld xmlns:a="http://schemas.openxmlformats.org/drawingml/2006/main" xmlns:r="http://schemas.openxmlformats.org/officeDocument/2006/relationships" xmlns:p="http://schemas.openxmlformats.org/presentationml/2006/main">
+<p:sld xmlns:a="http://schemas.openxmlformats.org/drawingml/2006/main" xmlns:p="http://schemas.openxmlformats.org/presentationml/2006/main" xmlns:r="http://schemas.openxmlformats.org/officeDocument/2006/relationships">
   <p:cSld>
     <p:bg>
       <p:bgPr>
@@ -11997,14 +11850,7 @@
         <p:cNvGrpSpPr/>
         <p:nvPr/>
       </p:nvGrpSpPr>
-      <p:grpSpPr>
-        <a:xfrm>
-          <a:off x="0" y="0"/>
-          <a:ext cx="0" cy="0"/>
-          <a:chOff x="0" y="0"/>
-          <a:chExt cx="0" cy="0"/>
-        </a:xfrm>
-      </p:grpSpPr>
+      <p:grpSpPr/>
       <p:sp>
         <p:nvSpPr>
           <p:cNvPr id="2" name="Rectangle 1"/>
@@ -12046,7 +11892,6 @@
           <a:lstStyle/>
           <a:p>
             <a:pPr algn="ctr"/>
-            <a:endParaRPr/>
           </a:p>
         </p:txBody>
       </p:sp>
@@ -12067,7 +11912,7 @@
           <a:noFill/>
         </p:spPr>
         <p:txBody>
-          <a:bodyPr wrap="square" lIns="0" tIns="0" rIns="0" bIns="0" anchor="t">
+          <a:bodyPr wrap="square" anchor="t" lIns="0" rIns="0" tIns="0" bIns="0">
             <a:spAutoFit/>
           </a:bodyPr>
           <a:lstStyle/>
@@ -12101,7 +11946,7 @@
           <a:noFill/>
         </p:spPr>
         <p:txBody>
-          <a:bodyPr wrap="square" lIns="0" tIns="0" rIns="0" bIns="0" anchor="t">
+          <a:bodyPr wrap="square" anchor="t" lIns="0" rIns="0" tIns="0" bIns="0">
             <a:spAutoFit/>
           </a:bodyPr>
           <a:lstStyle/>
@@ -12191,7 +12036,6 @@
           <a:lstStyle/>
           <a:p>
             <a:pPr algn="ctr"/>
-            <a:endParaRPr/>
           </a:p>
         </p:txBody>
       </p:sp>
@@ -12212,7 +12056,7 @@
           <a:noFill/>
         </p:spPr>
         <p:txBody>
-          <a:bodyPr wrap="square" lIns="0" tIns="0" rIns="0" bIns="0" anchor="t">
+          <a:bodyPr wrap="square" anchor="t" lIns="0" rIns="0" tIns="0" bIns="0">
             <a:spAutoFit/>
           </a:bodyPr>
           <a:lstStyle/>
@@ -12255,13 +12099,21 @@
           <a:noFill/>
         </p:spPr>
         <p:txBody>
-          <a:bodyPr wrap="square" lIns="0" tIns="0" rIns="0" bIns="0" anchor="t">
+          <a:bodyPr wrap="square" anchor="t" lIns="0" rIns="0" tIns="0" bIns="0">
             <a:spAutoFit/>
           </a:bodyPr>
           <a:lstStyle/>
           <a:p>
             <a:pPr algn="r"/>
-            <a:endParaRPr/>
+            <a:r>
+              <a:rPr sz="1100" b="0" i="0">
+                <a:solidFill>
+                  <a:srgbClr val="7A7A7A"/>
+                </a:solidFill>
+                <a:latin typeface="Roboto"/>
+              </a:rPr>
+              <a:t/>
+            </a:r>
           </a:p>
         </p:txBody>
       </p:sp>
@@ -12274,7 +12126,7 @@
 </file>
 
 <file path=ppt/slides/slide4.xml><?xml version="1.0" encoding="utf-8"?>
-<p:sld xmlns:a="http://schemas.openxmlformats.org/drawingml/2006/main" xmlns:r="http://schemas.openxmlformats.org/officeDocument/2006/relationships" xmlns:p="http://schemas.openxmlformats.org/presentationml/2006/main">
+<p:sld xmlns:a="http://schemas.openxmlformats.org/drawingml/2006/main" xmlns:p="http://schemas.openxmlformats.org/presentationml/2006/main" xmlns:r="http://schemas.openxmlformats.org/officeDocument/2006/relationships">
   <p:cSld>
     <p:bg>
       <p:bgPr>
@@ -12290,14 +12142,7 @@
         <p:cNvGrpSpPr/>
         <p:nvPr/>
       </p:nvGrpSpPr>
-      <p:grpSpPr>
-        <a:xfrm>
-          <a:off x="0" y="0"/>
-          <a:ext cx="0" cy="0"/>
-          <a:chOff x="0" y="0"/>
-          <a:chExt cx="0" cy="0"/>
-        </a:xfrm>
-      </p:grpSpPr>
+      <p:grpSpPr/>
       <p:sp>
         <p:nvSpPr>
           <p:cNvPr id="2" name="TextBox 1"/>
@@ -12315,7 +12160,7 @@
           <a:noFill/>
         </p:spPr>
         <p:txBody>
-          <a:bodyPr wrap="square" lIns="0" tIns="0" rIns="0" bIns="0" anchor="t">
+          <a:bodyPr wrap="square" anchor="t" lIns="0" rIns="0" tIns="0" bIns="0">
             <a:spAutoFit/>
           </a:bodyPr>
           <a:lstStyle/>
@@ -12373,7 +12218,6 @@
           <a:lstStyle/>
           <a:p>
             <a:pPr algn="ctr"/>
-            <a:endParaRPr/>
           </a:p>
         </p:txBody>
       </p:sp>
@@ -12394,7 +12238,7 @@
           <a:noFill/>
         </p:spPr>
         <p:txBody>
-          <a:bodyPr wrap="square" lIns="0" tIns="0" rIns="0" bIns="0" anchor="ctr">
+          <a:bodyPr wrap="square" anchor="ctr" lIns="0" rIns="0" tIns="0" bIns="0">
             <a:spAutoFit/>
           </a:bodyPr>
           <a:lstStyle/>
@@ -12534,7 +12378,6 @@
           <a:lstStyle/>
           <a:p>
             <a:pPr algn="ctr"/>
-            <a:endParaRPr/>
           </a:p>
         </p:txBody>
       </p:sp>
@@ -12555,7 +12398,7 @@
           <a:noFill/>
         </p:spPr>
         <p:txBody>
-          <a:bodyPr wrap="square" lIns="0" tIns="0" rIns="0" bIns="0" anchor="t">
+          <a:bodyPr wrap="square" anchor="t" lIns="0" rIns="0" tIns="0" bIns="0">
             <a:spAutoFit/>
           </a:bodyPr>
           <a:lstStyle/>
@@ -12598,7 +12441,7 @@
           <a:noFill/>
         </p:spPr>
         <p:txBody>
-          <a:bodyPr wrap="square" lIns="0" tIns="0" rIns="0" bIns="0" anchor="t">
+          <a:bodyPr wrap="square" anchor="t" lIns="0" rIns="0" tIns="0" bIns="0">
             <a:spAutoFit/>
           </a:bodyPr>
           <a:lstStyle/>
@@ -12625,7 +12468,7 @@
 </file>
 
 <file path=ppt/slides/slide5.xml><?xml version="1.0" encoding="utf-8"?>
-<p:sld xmlns:a="http://schemas.openxmlformats.org/drawingml/2006/main" xmlns:r="http://schemas.openxmlformats.org/officeDocument/2006/relationships" xmlns:p="http://schemas.openxmlformats.org/presentationml/2006/main">
+<p:sld xmlns:a="http://schemas.openxmlformats.org/drawingml/2006/main" xmlns:p="http://schemas.openxmlformats.org/presentationml/2006/main" xmlns:r="http://schemas.openxmlformats.org/officeDocument/2006/relationships">
   <p:cSld>
     <p:bg>
       <p:bgPr>
@@ -12641,14 +12484,7 @@
         <p:cNvGrpSpPr/>
         <p:nvPr/>
       </p:nvGrpSpPr>
-      <p:grpSpPr>
-        <a:xfrm>
-          <a:off x="0" y="0"/>
-          <a:ext cx="0" cy="0"/>
-          <a:chOff x="0" y="0"/>
-          <a:chExt cx="0" cy="0"/>
-        </a:xfrm>
-      </p:grpSpPr>
+      <p:grpSpPr/>
       <p:sp>
         <p:nvSpPr>
           <p:cNvPr id="2" name="TextBox 1"/>
@@ -12666,7 +12502,7 @@
           <a:noFill/>
         </p:spPr>
         <p:txBody>
-          <a:bodyPr wrap="square" lIns="0" tIns="0" rIns="0" bIns="0" anchor="t">
+          <a:bodyPr wrap="square" anchor="t" lIns="0" rIns="0" tIns="0" bIns="0">
             <a:spAutoFit/>
           </a:bodyPr>
           <a:lstStyle/>
@@ -12724,7 +12560,6 @@
           <a:lstStyle/>
           <a:p>
             <a:pPr algn="ctr"/>
-            <a:endParaRPr/>
           </a:p>
         </p:txBody>
       </p:sp>
@@ -12745,7 +12580,7 @@
           <a:noFill/>
         </p:spPr>
         <p:txBody>
-          <a:bodyPr wrap="square" lIns="0" tIns="0" rIns="0" bIns="0" anchor="ctr">
+          <a:bodyPr wrap="square" anchor="ctr" lIns="0" rIns="0" tIns="0" bIns="0">
             <a:spAutoFit/>
           </a:bodyPr>
           <a:lstStyle/>
@@ -12885,7 +12720,6 @@
           <a:lstStyle/>
           <a:p>
             <a:pPr algn="ctr"/>
-            <a:endParaRPr/>
           </a:p>
         </p:txBody>
       </p:sp>
@@ -12906,7 +12740,7 @@
           <a:noFill/>
         </p:spPr>
         <p:txBody>
-          <a:bodyPr wrap="square" lIns="0" tIns="0" rIns="0" bIns="0" anchor="t">
+          <a:bodyPr wrap="square" anchor="t" lIns="0" rIns="0" tIns="0" bIns="0">
             <a:spAutoFit/>
           </a:bodyPr>
           <a:lstStyle/>
@@ -12949,7 +12783,7 @@
           <a:noFill/>
         </p:spPr>
         <p:txBody>
-          <a:bodyPr wrap="square" lIns="0" tIns="0" rIns="0" bIns="0" anchor="t">
+          <a:bodyPr wrap="square" anchor="t" lIns="0" rIns="0" tIns="0" bIns="0">
             <a:spAutoFit/>
           </a:bodyPr>
           <a:lstStyle/>
@@ -12976,7 +12810,7 @@
 </file>
 
 <file path=ppt/slides/slide6.xml><?xml version="1.0" encoding="utf-8"?>
-<p:sld xmlns:a="http://schemas.openxmlformats.org/drawingml/2006/main" xmlns:r="http://schemas.openxmlformats.org/officeDocument/2006/relationships" xmlns:p="http://schemas.openxmlformats.org/presentationml/2006/main">
+<p:sld xmlns:a="http://schemas.openxmlformats.org/drawingml/2006/main" xmlns:p="http://schemas.openxmlformats.org/presentationml/2006/main" xmlns:r="http://schemas.openxmlformats.org/officeDocument/2006/relationships">
   <p:cSld>
     <p:bg>
       <p:bgPr>
@@ -12992,14 +12826,7 @@
         <p:cNvGrpSpPr/>
         <p:nvPr/>
       </p:nvGrpSpPr>
-      <p:grpSpPr>
-        <a:xfrm>
-          <a:off x="0" y="0"/>
-          <a:ext cx="0" cy="0"/>
-          <a:chOff x="0" y="0"/>
-          <a:chExt cx="0" cy="0"/>
-        </a:xfrm>
-      </p:grpSpPr>
+      <p:grpSpPr/>
       <p:sp>
         <p:nvSpPr>
           <p:cNvPr id="2" name="TextBox 1"/>
@@ -13017,7 +12844,7 @@
           <a:noFill/>
         </p:spPr>
         <p:txBody>
-          <a:bodyPr wrap="square" lIns="0" tIns="0" rIns="0" bIns="0" anchor="t">
+          <a:bodyPr wrap="square" anchor="t" lIns="0" rIns="0" tIns="0" bIns="0">
             <a:spAutoFit/>
           </a:bodyPr>
           <a:lstStyle/>
@@ -13075,7 +12902,6 @@
           <a:lstStyle/>
           <a:p>
             <a:pPr algn="ctr"/>
-            <a:endParaRPr/>
           </a:p>
         </p:txBody>
       </p:sp>
@@ -13096,7 +12922,7 @@
           <a:noFill/>
         </p:spPr>
         <p:txBody>
-          <a:bodyPr wrap="square" lIns="0" tIns="0" rIns="0" bIns="0" anchor="ctr">
+          <a:bodyPr wrap="square" anchor="ctr" lIns="0" rIns="0" tIns="0" bIns="0">
             <a:spAutoFit/>
           </a:bodyPr>
           <a:lstStyle/>
@@ -13329,7 +13155,6 @@
           <a:lstStyle/>
           <a:p>
             <a:pPr algn="ctr"/>
-            <a:endParaRPr/>
           </a:p>
         </p:txBody>
       </p:sp>
@@ -13350,7 +13175,7 @@
           <a:noFill/>
         </p:spPr>
         <p:txBody>
-          <a:bodyPr wrap="square" lIns="0" tIns="0" rIns="0" bIns="0" anchor="t">
+          <a:bodyPr wrap="square" anchor="t" lIns="0" rIns="0" tIns="0" bIns="0">
             <a:spAutoFit/>
           </a:bodyPr>
           <a:lstStyle/>
@@ -13393,7 +13218,7 @@
           <a:noFill/>
         </p:spPr>
         <p:txBody>
-          <a:bodyPr wrap="square" lIns="0" tIns="0" rIns="0" bIns="0" anchor="t">
+          <a:bodyPr wrap="square" anchor="t" lIns="0" rIns="0" tIns="0" bIns="0">
             <a:spAutoFit/>
           </a:bodyPr>
           <a:lstStyle/>
@@ -13420,7 +13245,7 @@
 </file>
 
 <file path=ppt/slides/slide7.xml><?xml version="1.0" encoding="utf-8"?>
-<p:sld xmlns:a="http://schemas.openxmlformats.org/drawingml/2006/main" xmlns:r="http://schemas.openxmlformats.org/officeDocument/2006/relationships" xmlns:p="http://schemas.openxmlformats.org/presentationml/2006/main">
+<p:sld xmlns:a="http://schemas.openxmlformats.org/drawingml/2006/main" xmlns:p="http://schemas.openxmlformats.org/presentationml/2006/main" xmlns:r="http://schemas.openxmlformats.org/officeDocument/2006/relationships">
   <p:cSld>
     <p:bg>
       <p:bgPr>
@@ -13436,14 +13261,7 @@
         <p:cNvGrpSpPr/>
         <p:nvPr/>
       </p:nvGrpSpPr>
-      <p:grpSpPr>
-        <a:xfrm>
-          <a:off x="0" y="0"/>
-          <a:ext cx="0" cy="0"/>
-          <a:chOff x="0" y="0"/>
-          <a:chExt cx="0" cy="0"/>
-        </a:xfrm>
-      </p:grpSpPr>
+      <p:grpSpPr/>
       <p:sp>
         <p:nvSpPr>
           <p:cNvPr id="2" name="TextBox 1"/>
@@ -13461,7 +13279,7 @@
           <a:noFill/>
         </p:spPr>
         <p:txBody>
-          <a:bodyPr wrap="square" lIns="0" tIns="0" rIns="0" bIns="0" anchor="t">
+          <a:bodyPr wrap="square" anchor="t" lIns="0" rIns="0" tIns="0" bIns="0">
             <a:spAutoFit/>
           </a:bodyPr>
           <a:lstStyle/>
@@ -13519,7 +13337,6 @@
           <a:lstStyle/>
           <a:p>
             <a:pPr algn="ctr"/>
-            <a:endParaRPr/>
           </a:p>
         </p:txBody>
       </p:sp>
@@ -13540,7 +13357,7 @@
           <a:noFill/>
         </p:spPr>
         <p:txBody>
-          <a:bodyPr wrap="square" lIns="0" tIns="0" rIns="0" bIns="0" anchor="ctr">
+          <a:bodyPr wrap="square" anchor="ctr" lIns="0" rIns="0" tIns="0" bIns="0">
             <a:spAutoFit/>
           </a:bodyPr>
           <a:lstStyle/>
@@ -13711,7 +13528,6 @@
           <a:lstStyle/>
           <a:p>
             <a:pPr algn="ctr"/>
-            <a:endParaRPr/>
           </a:p>
         </p:txBody>
       </p:sp>
@@ -13732,7 +13548,7 @@
           <a:noFill/>
         </p:spPr>
         <p:txBody>
-          <a:bodyPr wrap="square" lIns="0" tIns="0" rIns="0" bIns="0" anchor="t">
+          <a:bodyPr wrap="square" anchor="t" lIns="0" rIns="0" tIns="0" bIns="0">
             <a:spAutoFit/>
           </a:bodyPr>
           <a:lstStyle/>
@@ -13775,7 +13591,7 @@
           <a:noFill/>
         </p:spPr>
         <p:txBody>
-          <a:bodyPr wrap="square" lIns="0" tIns="0" rIns="0" bIns="0" anchor="t">
+          <a:bodyPr wrap="square" anchor="t" lIns="0" rIns="0" tIns="0" bIns="0">
             <a:spAutoFit/>
           </a:bodyPr>
           <a:lstStyle/>
@@ -13802,7 +13618,7 @@
 </file>
 
 <file path=ppt/slides/slide8.xml><?xml version="1.0" encoding="utf-8"?>
-<p:sld xmlns:a="http://schemas.openxmlformats.org/drawingml/2006/main" xmlns:r="http://schemas.openxmlformats.org/officeDocument/2006/relationships" xmlns:p="http://schemas.openxmlformats.org/presentationml/2006/main">
+<p:sld xmlns:a="http://schemas.openxmlformats.org/drawingml/2006/main" xmlns:p="http://schemas.openxmlformats.org/presentationml/2006/main" xmlns:r="http://schemas.openxmlformats.org/officeDocument/2006/relationships">
   <p:cSld>
     <p:bg>
       <p:bgPr>
@@ -13818,14 +13634,7 @@
         <p:cNvGrpSpPr/>
         <p:nvPr/>
       </p:nvGrpSpPr>
-      <p:grpSpPr>
-        <a:xfrm>
-          <a:off x="0" y="0"/>
-          <a:ext cx="0" cy="0"/>
-          <a:chOff x="0" y="0"/>
-          <a:chExt cx="0" cy="0"/>
-        </a:xfrm>
-      </p:grpSpPr>
+      <p:grpSpPr/>
       <p:sp>
         <p:nvSpPr>
           <p:cNvPr id="2" name="Rectangle 1"/>
@@ -13867,7 +13676,6 @@
           <a:lstStyle/>
           <a:p>
             <a:pPr algn="ctr"/>
-            <a:endParaRPr/>
           </a:p>
         </p:txBody>
       </p:sp>
@@ -13941,7 +13749,7 @@
           <a:noFill/>
         </p:spPr>
         <p:txBody>
-          <a:bodyPr wrap="square" lIns="0" tIns="0" rIns="0" bIns="0" anchor="ctr">
+          <a:bodyPr wrap="square" anchor="ctr" lIns="0" rIns="0" tIns="0" bIns="0">
             <a:spAutoFit/>
           </a:bodyPr>
           <a:lstStyle/>
@@ -13967,7 +13775,7 @@
         <p:spPr>
           <a:xfrm>
             <a:off x="658368" y="1554480"/>
-            <a:ext cx="10881360" cy="3860224"/>
+            <a:ext cx="10881360" cy="4297680"/>
           </a:xfrm>
           <a:prstGeom prst="rect">
             <a:avLst/>
@@ -13975,7 +13783,7 @@
           <a:noFill/>
         </p:spPr>
         <p:txBody>
-          <a:bodyPr wrap="square" lIns="0" tIns="0" rIns="0" bIns="0" anchor="t">
+          <a:bodyPr wrap="square" anchor="t" lIns="0" rIns="0" tIns="0" bIns="0">
             <a:spAutoFit/>
           </a:bodyPr>
           <a:lstStyle/>
@@ -13992,7 +13800,7 @@
               </a:spcAft>
             </a:pPr>
             <a:r>
-              <a:rPr sz="2400" b="1" i="0" dirty="0">
+              <a:rPr sz="1700" b="1" i="0">
                 <a:solidFill>
                   <a:srgbClr val="EDAB0C"/>
                 </a:solidFill>
@@ -14001,7 +13809,7 @@
               <a:t>■  </a:t>
             </a:r>
             <a:r>
-              <a:rPr sz="2400" b="0" i="0" dirty="0">
+              <a:rPr sz="1700" b="0" i="0">
                 <a:solidFill>
                   <a:srgbClr val="2A2929"/>
                 </a:solidFill>
@@ -14023,7 +13831,7 @@
               </a:spcAft>
             </a:pPr>
             <a:r>
-              <a:rPr sz="2400" b="1" i="0" dirty="0">
+              <a:rPr sz="1700" b="1" i="0">
                 <a:solidFill>
                   <a:srgbClr val="EDAB0C"/>
                 </a:solidFill>
@@ -14032,7 +13840,7 @@
               <a:t>■  </a:t>
             </a:r>
             <a:r>
-              <a:rPr sz="2400" b="0" i="0" dirty="0">
+              <a:rPr sz="1700" b="0" i="0">
                 <a:solidFill>
                   <a:srgbClr val="2A2929"/>
                 </a:solidFill>
@@ -14054,7 +13862,7 @@
               </a:spcAft>
             </a:pPr>
             <a:r>
-              <a:rPr sz="2000" b="0" i="0" dirty="0">
+              <a:rPr sz="1400" b="0" i="0">
                 <a:solidFill>
                   <a:srgbClr val="7A7A7A"/>
                 </a:solidFill>
@@ -14063,22 +13871,13 @@
               <a:t>–  </a:t>
             </a:r>
             <a:r>
-              <a:rPr sz="2000" b="0" i="0" dirty="0" err="1">
+              <a:rPr sz="1400" b="0" i="0">
                 <a:solidFill>
                   <a:srgbClr val="2A2929"/>
                 </a:solidFill>
                 <a:latin typeface="Roboto"/>
               </a:rPr>
-              <a:t>Prioritise</a:t>
-            </a:r>
-            <a:r>
-              <a:rPr sz="2000" b="0" i="0" dirty="0">
-                <a:solidFill>
-                  <a:srgbClr val="2A2929"/>
-                </a:solidFill>
-                <a:latin typeface="Roboto"/>
-              </a:rPr>
-              <a:t> your proposed changes (from your gap analysis).</a:t>
+              <a:t>Prioritise your proposed changes (from your gap analysis).</a:t>
             </a:r>
           </a:p>
           <a:p>
@@ -14094,7 +13893,7 @@
               </a:spcAft>
             </a:pPr>
             <a:r>
-              <a:rPr sz="2000" b="0" i="0" dirty="0">
+              <a:rPr sz="1400" b="0" i="0">
                 <a:solidFill>
                   <a:srgbClr val="7A7A7A"/>
                 </a:solidFill>
@@ -14103,7 +13902,7 @@
               <a:t>–  </a:t>
             </a:r>
             <a:r>
-              <a:rPr sz="2000" b="0" i="0" dirty="0">
+              <a:rPr sz="1400" b="0" i="0">
                 <a:solidFill>
                   <a:srgbClr val="2A2929"/>
                 </a:solidFill>
@@ -14125,7 +13924,7 @@
               </a:spcAft>
             </a:pPr>
             <a:r>
-              <a:rPr sz="2000" b="0" i="0" dirty="0">
+              <a:rPr sz="1400" b="0" i="0">
                 <a:solidFill>
                   <a:srgbClr val="7A7A7A"/>
                 </a:solidFill>
@@ -14134,7 +13933,7 @@
               <a:t>–  </a:t>
             </a:r>
             <a:r>
-              <a:rPr sz="2000" b="0" i="0" dirty="0">
+              <a:rPr sz="1400" b="0" i="0">
                 <a:solidFill>
                   <a:srgbClr val="2A2929"/>
                 </a:solidFill>
@@ -14156,7 +13955,7 @@
               </a:spcAft>
             </a:pPr>
             <a:r>
-              <a:rPr sz="2000" b="0" i="0" dirty="0">
+              <a:rPr sz="1400" b="0" i="0">
                 <a:solidFill>
                   <a:srgbClr val="7A7A7A"/>
                 </a:solidFill>
@@ -14165,7 +13964,7 @@
               <a:t>–  </a:t>
             </a:r>
             <a:r>
-              <a:rPr sz="2000" b="0" i="0" dirty="0">
+              <a:rPr sz="1400" b="0" i="0">
                 <a:solidFill>
                   <a:srgbClr val="2A2929"/>
                 </a:solidFill>
@@ -14187,7 +13986,7 @@
               </a:spcAft>
             </a:pPr>
             <a:r>
-              <a:rPr sz="2400" b="1" i="0" dirty="0">
+              <a:rPr sz="1700" b="1" i="0">
                 <a:solidFill>
                   <a:srgbClr val="EDAB0C"/>
                 </a:solidFill>
@@ -14196,7 +13995,7 @@
               <a:t>■  </a:t>
             </a:r>
             <a:r>
-              <a:rPr sz="2400" b="0" i="0" dirty="0">
+              <a:rPr sz="1700" b="0" i="0">
                 <a:solidFill>
                   <a:srgbClr val="2A2929"/>
                 </a:solidFill>
@@ -14218,7 +14017,7 @@
               </a:spcAft>
             </a:pPr>
             <a:r>
-              <a:rPr sz="2400" b="1" i="0" dirty="0">
+              <a:rPr sz="1700" b="1" i="0">
                 <a:solidFill>
                   <a:srgbClr val="EDAB0C"/>
                 </a:solidFill>
@@ -14227,7 +14026,7 @@
               <a:t>■  </a:t>
             </a:r>
             <a:r>
-              <a:rPr sz="2400" b="0" i="0" dirty="0">
+              <a:rPr sz="1700" b="0" i="0">
                 <a:solidFill>
                   <a:srgbClr val="2A2929"/>
                 </a:solidFill>
@@ -14281,7 +14080,6 @@
           <a:lstStyle/>
           <a:p>
             <a:pPr algn="ctr"/>
-            <a:endParaRPr/>
           </a:p>
         </p:txBody>
       </p:sp>
@@ -14302,7 +14100,7 @@
           <a:noFill/>
         </p:spPr>
         <p:txBody>
-          <a:bodyPr wrap="square" lIns="0" tIns="0" rIns="0" bIns="0" anchor="ctr">
+          <a:bodyPr wrap="square" anchor="ctr" lIns="0" rIns="0" tIns="0" bIns="0">
             <a:spAutoFit/>
           </a:bodyPr>
           <a:lstStyle/>
@@ -14360,7 +14158,6 @@
           <a:lstStyle/>
           <a:p>
             <a:pPr algn="ctr"/>
-            <a:endParaRPr/>
           </a:p>
         </p:txBody>
       </p:sp>
@@ -14381,7 +14178,7 @@
           <a:noFill/>
         </p:spPr>
         <p:txBody>
-          <a:bodyPr wrap="square" lIns="0" tIns="0" rIns="0" bIns="0" anchor="t">
+          <a:bodyPr wrap="square" anchor="t" lIns="0" rIns="0" tIns="0" bIns="0">
             <a:spAutoFit/>
           </a:bodyPr>
           <a:lstStyle/>
@@ -14424,7 +14221,7 @@
           <a:noFill/>
         </p:spPr>
         <p:txBody>
-          <a:bodyPr wrap="square" lIns="0" tIns="0" rIns="0" bIns="0" anchor="t">
+          <a:bodyPr wrap="square" anchor="t" lIns="0" rIns="0" tIns="0" bIns="0">
             <a:spAutoFit/>
           </a:bodyPr>
           <a:lstStyle/>
@@ -14451,7 +14248,7 @@
 </file>
 
 <file path=ppt/slides/slide9.xml><?xml version="1.0" encoding="utf-8"?>
-<p:sld xmlns:a="http://schemas.openxmlformats.org/drawingml/2006/main" xmlns:r="http://schemas.openxmlformats.org/officeDocument/2006/relationships" xmlns:p="http://schemas.openxmlformats.org/presentationml/2006/main">
+<p:sld xmlns:a="http://schemas.openxmlformats.org/drawingml/2006/main" xmlns:p="http://schemas.openxmlformats.org/presentationml/2006/main" xmlns:r="http://schemas.openxmlformats.org/officeDocument/2006/relationships">
   <p:cSld>
     <p:bg>
       <p:bgPr>
@@ -14467,14 +14264,7 @@
         <p:cNvGrpSpPr/>
         <p:nvPr/>
       </p:nvGrpSpPr>
-      <p:grpSpPr>
-        <a:xfrm>
-          <a:off x="0" y="0"/>
-          <a:ext cx="0" cy="0"/>
-          <a:chOff x="0" y="0"/>
-          <a:chExt cx="0" cy="0"/>
-        </a:xfrm>
-      </p:grpSpPr>
+      <p:grpSpPr/>
       <p:sp>
         <p:nvSpPr>
           <p:cNvPr id="2" name="TextBox 1"/>
@@ -14492,7 +14282,7 @@
           <a:noFill/>
         </p:spPr>
         <p:txBody>
-          <a:bodyPr wrap="square" lIns="0" tIns="0" rIns="0" bIns="0" anchor="t">
+          <a:bodyPr wrap="square" anchor="t" lIns="0" rIns="0" tIns="0" bIns="0">
             <a:spAutoFit/>
           </a:bodyPr>
           <a:lstStyle/>
@@ -14566,7 +14356,6 @@
           <a:lstStyle/>
           <a:p>
             <a:pPr algn="ctr"/>
-            <a:endParaRPr/>
           </a:p>
         </p:txBody>
       </p:sp>
@@ -14613,7 +14402,6 @@
           <a:lstStyle/>
           <a:p>
             <a:pPr algn="ctr"/>
-            <a:endParaRPr/>
           </a:p>
         </p:txBody>
       </p:sp>
@@ -14658,7 +14446,6 @@
           <a:lstStyle/>
           <a:p>
             <a:pPr algn="ctr"/>
-            <a:endParaRPr/>
           </a:p>
         </p:txBody>
       </p:sp>
@@ -14679,7 +14466,7 @@
           <a:noFill/>
         </p:spPr>
         <p:txBody>
-          <a:bodyPr wrap="square" lIns="0" tIns="0" rIns="0" bIns="0" anchor="ctr">
+          <a:bodyPr wrap="square" anchor="ctr" lIns="0" rIns="0" tIns="0" bIns="0">
             <a:spAutoFit/>
           </a:bodyPr>
           <a:lstStyle/>
@@ -14744,7 +14531,6 @@
           <a:lstStyle/>
           <a:p>
             <a:pPr algn="ctr"/>
-            <a:endParaRPr/>
           </a:p>
         </p:txBody>
       </p:sp>
@@ -14789,7 +14575,6 @@
           <a:lstStyle/>
           <a:p>
             <a:pPr algn="ctr"/>
-            <a:endParaRPr/>
           </a:p>
         </p:txBody>
       </p:sp>
@@ -14810,7 +14595,7 @@
           <a:noFill/>
         </p:spPr>
         <p:txBody>
-          <a:bodyPr wrap="square" lIns="0" tIns="0" rIns="0" bIns="0" anchor="ctr">
+          <a:bodyPr wrap="square" anchor="ctr" lIns="0" rIns="0" tIns="0" bIns="0">
             <a:spAutoFit/>
           </a:bodyPr>
           <a:lstStyle/>
@@ -14875,7 +14660,6 @@
           <a:lstStyle/>
           <a:p>
             <a:pPr algn="ctr"/>
-            <a:endParaRPr/>
           </a:p>
         </p:txBody>
       </p:sp>
@@ -14920,7 +14704,6 @@
           <a:lstStyle/>
           <a:p>
             <a:pPr algn="ctr"/>
-            <a:endParaRPr/>
           </a:p>
         </p:txBody>
       </p:sp>
@@ -14941,7 +14724,7 @@
           <a:noFill/>
         </p:spPr>
         <p:txBody>
-          <a:bodyPr wrap="square" lIns="0" tIns="0" rIns="0" bIns="0" anchor="ctr">
+          <a:bodyPr wrap="square" anchor="ctr" lIns="0" rIns="0" tIns="0" bIns="0">
             <a:spAutoFit/>
           </a:bodyPr>
           <a:lstStyle/>
@@ -15004,7 +14787,6 @@
           <a:lstStyle/>
           <a:p>
             <a:pPr algn="ctr"/>
-            <a:endParaRPr/>
           </a:p>
         </p:txBody>
       </p:sp>
@@ -15025,7 +14807,7 @@
           <a:noFill/>
         </p:spPr>
         <p:txBody>
-          <a:bodyPr wrap="square" lIns="0" tIns="0" rIns="0" bIns="0" anchor="t">
+          <a:bodyPr wrap="square" anchor="t" lIns="0" rIns="0" tIns="0" bIns="0">
             <a:spAutoFit/>
           </a:bodyPr>
           <a:lstStyle/>
@@ -15068,7 +14850,7 @@
           <a:noFill/>
         </p:spPr>
         <p:txBody>
-          <a:bodyPr wrap="square" lIns="0" tIns="0" rIns="0" bIns="0" anchor="t">
+          <a:bodyPr wrap="square" anchor="t" lIns="0" rIns="0" tIns="0" bIns="0">
             <a:spAutoFit/>
           </a:bodyPr>
           <a:lstStyle/>
@@ -15425,44 +15207,44 @@
         <a:sysClr val="window" lastClr="FFFFFF"/>
       </a:lt1>
       <a:dk2>
-        <a:srgbClr val="0E2841"/>
+        <a:srgbClr val="1F497D"/>
       </a:dk2>
       <a:lt2>
-        <a:srgbClr val="E8E8E8"/>
+        <a:srgbClr val="EEECE1"/>
       </a:lt2>
       <a:accent1>
-        <a:srgbClr val="156082"/>
+        <a:srgbClr val="4F81BD"/>
       </a:accent1>
       <a:accent2>
-        <a:srgbClr val="E97132"/>
+        <a:srgbClr val="C0504D"/>
       </a:accent2>
       <a:accent3>
-        <a:srgbClr val="196B24"/>
+        <a:srgbClr val="9BBB59"/>
       </a:accent3>
       <a:accent4>
-        <a:srgbClr val="0F9ED5"/>
+        <a:srgbClr val="8064A2"/>
       </a:accent4>
       <a:accent5>
-        <a:srgbClr val="A02B93"/>
+        <a:srgbClr val="4BACC6"/>
       </a:accent5>
       <a:accent6>
-        <a:srgbClr val="4EA72E"/>
+        <a:srgbClr val="F79646"/>
       </a:accent6>
       <a:hlink>
-        <a:srgbClr val="467886"/>
+        <a:srgbClr val="0000FF"/>
       </a:hlink>
       <a:folHlink>
-        <a:srgbClr val="96607D"/>
+        <a:srgbClr val="800080"/>
       </a:folHlink>
     </a:clrScheme>
     <a:fontScheme name="Office">
       <a:majorFont>
-        <a:latin typeface="Aptos Display" panose="02110004020202020204"/>
+        <a:latin typeface="Calibri"/>
         <a:ea typeface=""/>
         <a:cs typeface=""/>
-        <a:font script="Jpan" typeface="游ゴシック Light"/>
+        <a:font script="Jpan" typeface="ＭＳ Ｐゴシック"/>
         <a:font script="Hang" typeface="맑은 고딕"/>
-        <a:font script="Hans" typeface="等线 Light"/>
+        <a:font script="Hans" typeface="宋体"/>
         <a:font script="Hant" typeface="新細明體"/>
         <a:font script="Arab" typeface="Times New Roman"/>
         <a:font script="Hebr" typeface="Times New Roman"/>
@@ -15490,31 +15272,14 @@
         <a:font script="Viet" typeface="Times New Roman"/>
         <a:font script="Uigh" typeface="Microsoft Uighur"/>
         <a:font script="Geor" typeface="Sylfaen"/>
-        <a:font script="Armn" typeface="Arial"/>
-        <a:font script="Bugi" typeface="Leelawadee UI"/>
-        <a:font script="Bopo" typeface="Microsoft JhengHei"/>
-        <a:font script="Java" typeface="Javanese Text"/>
-        <a:font script="Lisu" typeface="Segoe UI"/>
-        <a:font script="Mymr" typeface="Myanmar Text"/>
-        <a:font script="Nkoo" typeface="Ebrima"/>
-        <a:font script="Olck" typeface="Nirmala UI"/>
-        <a:font script="Osma" typeface="Ebrima"/>
-        <a:font script="Phag" typeface="Phagspa"/>
-        <a:font script="Syrn" typeface="Estrangelo Edessa"/>
-        <a:font script="Syrj" typeface="Estrangelo Edessa"/>
-        <a:font script="Syre" typeface="Estrangelo Edessa"/>
-        <a:font script="Sora" typeface="Nirmala UI"/>
-        <a:font script="Tale" typeface="Microsoft Tai Le"/>
-        <a:font script="Talu" typeface="Microsoft New Tai Lue"/>
-        <a:font script="Tfng" typeface="Ebrima"/>
       </a:majorFont>
       <a:minorFont>
-        <a:latin typeface="Aptos" panose="02110004020202020204"/>
+        <a:latin typeface="Calibri"/>
         <a:ea typeface=""/>
         <a:cs typeface=""/>
-        <a:font script="Jpan" typeface="游ゴシック"/>
+        <a:font script="Jpan" typeface="ＭＳ Ｐゴシック"/>
         <a:font script="Hang" typeface="맑은 고딕"/>
-        <a:font script="Hans" typeface="等线"/>
+        <a:font script="Hans" typeface="宋体"/>
         <a:font script="Hant" typeface="新細明體"/>
         <a:font script="Arab" typeface="Arial"/>
         <a:font script="Hebr" typeface="Arial"/>
@@ -15542,23 +15307,6 @@
         <a:font script="Viet" typeface="Arial"/>
         <a:font script="Uigh" typeface="Microsoft Uighur"/>
         <a:font script="Geor" typeface="Sylfaen"/>
-        <a:font script="Armn" typeface="Arial"/>
-        <a:font script="Bugi" typeface="Leelawadee UI"/>
-        <a:font script="Bopo" typeface="Microsoft JhengHei"/>
-        <a:font script="Java" typeface="Javanese Text"/>
-        <a:font script="Lisu" typeface="Segoe UI"/>
-        <a:font script="Mymr" typeface="Myanmar Text"/>
-        <a:font script="Nkoo" typeface="Ebrima"/>
-        <a:font script="Olck" typeface="Nirmala UI"/>
-        <a:font script="Osma" typeface="Ebrima"/>
-        <a:font script="Phag" typeface="Phagspa"/>
-        <a:font script="Syrn" typeface="Estrangelo Edessa"/>
-        <a:font script="Syrj" typeface="Estrangelo Edessa"/>
-        <a:font script="Syre" typeface="Estrangelo Edessa"/>
-        <a:font script="Sora" typeface="Nirmala UI"/>
-        <a:font script="Tale" typeface="Microsoft Tai Le"/>
-        <a:font script="Talu" typeface="Microsoft New Tai Lue"/>
-        <a:font script="Tfng" typeface="Ebrima"/>
       </a:minorFont>
     </a:fontScheme>
     <a:fmtScheme name="Office">
@@ -15570,136 +15318,180 @@
           <a:gsLst>
             <a:gs pos="0">
               <a:schemeClr val="phClr">
-                <a:lumMod val="110000"/>
-                <a:satMod val="105000"/>
-                <a:tint val="67000"/>
+                <a:tint val="50000"/>
+                <a:satMod val="300000"/>
               </a:schemeClr>
             </a:gs>
-            <a:gs pos="50000">
+            <a:gs pos="35000">
               <a:schemeClr val="phClr">
-                <a:lumMod val="105000"/>
-                <a:satMod val="103000"/>
-                <a:tint val="73000"/>
+                <a:tint val="37000"/>
+                <a:satMod val="300000"/>
               </a:schemeClr>
             </a:gs>
             <a:gs pos="100000">
               <a:schemeClr val="phClr">
-                <a:lumMod val="105000"/>
-                <a:satMod val="109000"/>
-                <a:tint val="81000"/>
+                <a:tint val="15000"/>
+                <a:satMod val="350000"/>
               </a:schemeClr>
             </a:gs>
           </a:gsLst>
-          <a:lin ang="5400000" scaled="0"/>
+          <a:lin ang="16200000" scaled="1"/>
         </a:gradFill>
         <a:gradFill rotWithShape="1">
           <a:gsLst>
             <a:gs pos="0">
               <a:schemeClr val="phClr">
-                <a:satMod val="103000"/>
-                <a:lumMod val="102000"/>
-                <a:tint val="94000"/>
-              </a:schemeClr>
-            </a:gs>
-            <a:gs pos="50000">
-              <a:schemeClr val="phClr">
-                <a:satMod val="110000"/>
-                <a:lumMod val="100000"/>
+                <a:tint val="100000"/>
                 <a:shade val="100000"/>
+                <a:satMod val="130000"/>
               </a:schemeClr>
             </a:gs>
             <a:gs pos="100000">
               <a:schemeClr val="phClr">
-                <a:lumMod val="99000"/>
-                <a:satMod val="120000"/>
-                <a:shade val="78000"/>
+                <a:tint val="50000"/>
+                <a:shade val="100000"/>
+                <a:satMod val="350000"/>
               </a:schemeClr>
             </a:gs>
           </a:gsLst>
-          <a:lin ang="5400000" scaled="0"/>
+          <a:lin ang="16200000" scaled="0"/>
         </a:gradFill>
       </a:fillStyleLst>
       <a:lnStyleLst>
-        <a:ln w="12700" cap="flat" cmpd="sng" algn="ctr">
+        <a:ln w="9525" cap="flat" cmpd="sng" algn="ctr">
           <a:solidFill>
-            <a:schemeClr val="phClr"/>
+            <a:schemeClr val="phClr">
+              <a:shade val="95000"/>
+              <a:satMod val="105000"/>
+            </a:schemeClr>
           </a:solidFill>
           <a:prstDash val="solid"/>
-          <a:miter lim="800000"/>
-        </a:ln>
-        <a:ln w="19050" cap="flat" cmpd="sng" algn="ctr">
-          <a:solidFill>
-            <a:schemeClr val="phClr"/>
-          </a:solidFill>
-          <a:prstDash val="solid"/>
-          <a:miter lim="800000"/>
         </a:ln>
         <a:ln w="25400" cap="flat" cmpd="sng" algn="ctr">
           <a:solidFill>
             <a:schemeClr val="phClr"/>
           </a:solidFill>
           <a:prstDash val="solid"/>
-          <a:miter lim="800000"/>
+        </a:ln>
+        <a:ln w="38100" cap="flat" cmpd="sng" algn="ctr">
+          <a:solidFill>
+            <a:schemeClr val="phClr"/>
+          </a:solidFill>
+          <a:prstDash val="solid"/>
         </a:ln>
       </a:lnStyleLst>
       <a:effectStyleLst>
         <a:effectStyle>
-          <a:effectLst/>
-        </a:effectStyle>
-        <a:effectStyle>
-          <a:effectLst/>
+          <a:effectLst>
+            <a:outerShdw blurRad="40000" dist="20000" dir="5400000" rotWithShape="0">
+              <a:srgbClr val="000000">
+                <a:alpha val="38000"/>
+              </a:srgbClr>
+            </a:outerShdw>
+          </a:effectLst>
         </a:effectStyle>
         <a:effectStyle>
           <a:effectLst>
-            <a:outerShdw blurRad="57150" dist="19050" dir="5400000" algn="ctr" rotWithShape="0">
+            <a:outerShdw blurRad="40000" dist="23000" dir="5400000" rotWithShape="0">
               <a:srgbClr val="000000">
-                <a:alpha val="63000"/>
+                <a:alpha val="35000"/>
               </a:srgbClr>
             </a:outerShdw>
           </a:effectLst>
+        </a:effectStyle>
+        <a:effectStyle>
+          <a:effectLst>
+            <a:outerShdw blurRad="40000" dist="23000" dir="5400000" rotWithShape="0">
+              <a:srgbClr val="000000">
+                <a:alpha val="35000"/>
+              </a:srgbClr>
+            </a:outerShdw>
+          </a:effectLst>
+          <a:scene3d>
+            <a:camera prst="orthographicFront">
+              <a:rot lat="0" lon="0" rev="0"/>
+            </a:camera>
+            <a:lightRig rig="threePt" dir="t">
+              <a:rot lat="0" lon="0" rev="1200000"/>
+            </a:lightRig>
+          </a:scene3d>
+          <a:sp3d>
+            <a:bevelT w="63500" h="25400"/>
+          </a:sp3d>
         </a:effectStyle>
       </a:effectStyleLst>
       <a:bgFillStyleLst>
         <a:solidFill>
           <a:schemeClr val="phClr"/>
         </a:solidFill>
-        <a:solidFill>
-          <a:schemeClr val="phClr">
-            <a:tint val="95000"/>
-            <a:satMod val="170000"/>
-          </a:schemeClr>
-        </a:solidFill>
         <a:gradFill rotWithShape="1">
           <a:gsLst>
             <a:gs pos="0">
               <a:schemeClr val="phClr">
-                <a:tint val="93000"/>
-                <a:satMod val="150000"/>
-                <a:shade val="98000"/>
-                <a:lumMod val="102000"/>
+                <a:tint val="40000"/>
+                <a:satMod val="350000"/>
               </a:schemeClr>
             </a:gs>
-            <a:gs pos="50000">
+            <a:gs pos="40000">
               <a:schemeClr val="phClr">
-                <a:tint val="98000"/>
-                <a:satMod val="130000"/>
-                <a:shade val="90000"/>
-                <a:lumMod val="103000"/>
+                <a:tint val="45000"/>
+                <a:shade val="99000"/>
+                <a:satMod val="350000"/>
               </a:schemeClr>
             </a:gs>
             <a:gs pos="100000">
               <a:schemeClr val="phClr">
-                <a:shade val="63000"/>
-                <a:satMod val="120000"/>
+                <a:shade val="20000"/>
+                <a:satMod val="255000"/>
               </a:schemeClr>
             </a:gs>
           </a:gsLst>
-          <a:lin ang="5400000" scaled="0"/>
+          <a:path path="circle">
+            <a:fillToRect l="50000" t="-80000" r="50000" b="180000"/>
+          </a:path>
+        </a:gradFill>
+        <a:gradFill rotWithShape="1">
+          <a:gsLst>
+            <a:gs pos="0">
+              <a:schemeClr val="phClr">
+                <a:tint val="80000"/>
+                <a:satMod val="300000"/>
+              </a:schemeClr>
+            </a:gs>
+            <a:gs pos="100000">
+              <a:schemeClr val="phClr">
+                <a:shade val="30000"/>
+                <a:satMod val="200000"/>
+              </a:schemeClr>
+            </a:gs>
+          </a:gsLst>
+          <a:path path="circle">
+            <a:fillToRect l="50000" t="50000" r="50000" b="50000"/>
+          </a:path>
         </a:gradFill>
       </a:bgFillStyleLst>
     </a:fmtScheme>
   </a:themeElements>
   <a:objectDefaults>
+    <a:spDef>
+      <a:spPr/>
+      <a:bodyPr/>
+      <a:lstStyle/>
+      <a:style>
+        <a:lnRef idx="1">
+          <a:schemeClr val="accent1"/>
+        </a:lnRef>
+        <a:fillRef idx="3">
+          <a:schemeClr val="accent1"/>
+        </a:fillRef>
+        <a:effectRef idx="2">
+          <a:schemeClr val="accent1"/>
+        </a:effectRef>
+        <a:fontRef idx="minor">
+          <a:schemeClr val="lt1"/>
+        </a:fontRef>
+      </a:style>
+    </a:spDef>
     <a:lnDef>
       <a:spPr/>
       <a:bodyPr/>
@@ -15721,10 +15513,5 @@
     </a:lnDef>
   </a:objectDefaults>
   <a:extraClrSchemeLst/>
-  <a:extLst>
-    <a:ext uri="{05A4C25C-085E-4340-85A3-A5531E510DB2}">
-      <thm15:themeFamily xmlns:thm15="http://schemas.microsoft.com/office/thememl/2012/main" name="Office Theme" id="{2E142A2C-CD16-42D6-873A-C26D2A0506FA}" vid="{1BDDFF52-6CD6-40A5-AB3C-68EB2F1E4D0A}"/>
-    </a:ext>
-  </a:extLst>
 </a:theme>
 </file>
</xml_diff>